<commit_message>
docs(data): document 27-month green-lion-2024-2025 history + deals.json generality; regenerate deck
</commit_message>
<xml_diff>
--- a/presentation/LoanWhiz-Presentation.pptx
+++ b/presentation/LoanWhiz-Presentation.pptx
@@ -5281,7 +5281,7 @@
                 </a:solidFill>
                 <a:latin typeface="Calibri"/>
               </a:rPr>
-              <a:t>Open &amp; extensible</a:t>
+              <a:t>Data-agnostic &amp; extensible</a:t>
             </a:r>
             <a:r>
               <a:rPr sz="1350" b="0" i="0">
@@ -5290,7 +5290,7 @@
                 </a:solidFill>
                 <a:latin typeface="Calibri"/>
               </a:rPr>
-              <a:t> — Apache-2.0, config-driven multi-deal, add a primitive in a few lines.</a:t>
+              <a:t> — Apache-2.0; add a deal via data/deals.json (no code change), add a primitive in a few lines.</a:t>
             </a:r>
           </a:p>
         </p:txBody>
@@ -9214,7 +9214,7 @@
                 </a:solidFill>
                 <a:latin typeface="Calibri"/>
               </a:rPr>
-              <a:t>Docling extraction (prospectus → JSON)   ·   deeploans ETL / ESMA tape ingestion   ·   HuggingFace: Algoritmica/green-lion-2026</a:t>
+              <a:t>Docling extraction (prospectus → JSON)   ·   deeploans ETL / ESMA tape ingestion   ·   HuggingFace: green-lion-2026 + green-lion-2024-2025 (27-month history)</a:t>
             </a:r>
           </a:p>
         </p:txBody>
@@ -16959,7 +16959,7 @@
                 </a:solidFill>
                 <a:latin typeface="Calibri"/>
               </a:rPr>
-              <a:t>A complete synthetic Dutch RMBS released for the hackathon: prospectus + 3 monthly ESMA tapes + 3 investor reports.</a:t>
+              <a:t>A complete synthetic Dutch RMBS released for the hackathon: prospectus + 27 months of ESMA tapes (2024–2026) + 3 investor reports.</a:t>
             </a:r>
           </a:p>
         </p:txBody>
@@ -17059,7 +17059,7 @@
                 </a:solidFill>
                 <a:latin typeface="Calibri"/>
               </a:rPr>
-              <a:t>3</a:t>
+              <a:t>27</a:t>
             </a:r>
           </a:p>
         </p:txBody>
@@ -17104,7 +17104,7 @@
                 </a:solidFill>
                 <a:latin typeface="Calibri"/>
               </a:rPr>
-              <a:t>note tranches</a:t>
+              <a:t>monthly tapes</a:t>
             </a:r>
           </a:p>
         </p:txBody>
@@ -17149,7 +17149,7 @@
                 </a:solidFill>
                 <a:latin typeface="Calibri"/>
               </a:rPr>
-              <a:t>Class A (AAA) / B / C, with sizes &amp; subordination</a:t>
+              <a:t>Jan 2024 – Apr 2026 ESMA history (Jan-2026 gap)</a:t>
             </a:r>
           </a:p>
         </p:txBody>
@@ -18123,7 +18123,7 @@
                 </a:solidFill>
                 <a:latin typeface="Calibri"/>
               </a:rPr>
-              <a:t>Built to scale to more data</a:t>
+              <a:t>Data-agnostic by design</a:t>
             </a:r>
           </a:p>
         </p:txBody>
@@ -18177,7 +18177,7 @@
                 </a:solidFill>
                 <a:latin typeface="Calibri"/>
               </a:rPr>
-              <a:t>Config-driven multi-deal registry — add a deal as a dict, no code change.</a:t>
+              <a:t>Add a deal via data/deals.json — no code change; Green-Lion defaults fill the gaps.</a:t>
             </a:r>
           </a:p>
           <a:p>
@@ -18208,7 +18208,7 @@
                 </a:solidFill>
                 <a:latin typeface="Calibri"/>
               </a:rPr>
-              <a:t>Durable cache: extract once, then instant; copes with 4yr of monthly tapes.</a:t>
+              <a:t>Proven over 27 months of monthly tapes (2024–2026), not a single snapshot.</a:t>
             </a:r>
           </a:p>
           <a:p>
@@ -18239,7 +18239,7 @@
                 </a:solidFill>
                 <a:latin typeface="Calibri"/>
               </a:rPr>
-              <a:t>Cache lifecycle hardened so a cold rebuild never serves stale results.</a:t>
+              <a:t>Durable cache: extract once, then instant; deal-context keys resolve per deal.</a:t>
             </a:r>
           </a:p>
         </p:txBody>

</xml_diff>

<commit_message>
docs: refresh README/docs + regenerate deck for 27-month data & deals.json generality
* docs(data): document 27-month green-lion-2024-2025 history + deals.json generality; regenerate deck

* docs(data): drop unverified 71-column count from tape schema description

---------

Co-authored-by: Uzair <uzair@nairang.com>
</commit_message>
<xml_diff>
--- a/presentation/LoanWhiz-Presentation.pptx
+++ b/presentation/LoanWhiz-Presentation.pptx
@@ -5281,7 +5281,7 @@
                 </a:solidFill>
                 <a:latin typeface="Calibri"/>
               </a:rPr>
-              <a:t>Open &amp; extensible</a:t>
+              <a:t>Data-agnostic &amp; extensible</a:t>
             </a:r>
             <a:r>
               <a:rPr sz="1350" b="0" i="0">
@@ -5290,7 +5290,7 @@
                 </a:solidFill>
                 <a:latin typeface="Calibri"/>
               </a:rPr>
-              <a:t> — Apache-2.0, config-driven multi-deal, add a primitive in a few lines.</a:t>
+              <a:t> — Apache-2.0; add a deal via data/deals.json (no code change), add a primitive in a few lines.</a:t>
             </a:r>
           </a:p>
         </p:txBody>
@@ -9214,7 +9214,7 @@
                 </a:solidFill>
                 <a:latin typeface="Calibri"/>
               </a:rPr>
-              <a:t>Docling extraction (prospectus → JSON)   ·   deeploans ETL / ESMA tape ingestion   ·   HuggingFace: Algoritmica/green-lion-2026</a:t>
+              <a:t>Docling extraction (prospectus → JSON)   ·   deeploans ETL / ESMA tape ingestion   ·   HuggingFace: green-lion-2026 + green-lion-2024-2025 (27-month history)</a:t>
             </a:r>
           </a:p>
         </p:txBody>
@@ -16959,7 +16959,7 @@
                 </a:solidFill>
                 <a:latin typeface="Calibri"/>
               </a:rPr>
-              <a:t>A complete synthetic Dutch RMBS released for the hackathon: prospectus + 3 monthly ESMA tapes + 3 investor reports.</a:t>
+              <a:t>A complete synthetic Dutch RMBS released for the hackathon: prospectus + 27 months of ESMA tapes (2024–2026) + 3 investor reports.</a:t>
             </a:r>
           </a:p>
         </p:txBody>
@@ -17059,7 +17059,7 @@
                 </a:solidFill>
                 <a:latin typeface="Calibri"/>
               </a:rPr>
-              <a:t>3</a:t>
+              <a:t>27</a:t>
             </a:r>
           </a:p>
         </p:txBody>
@@ -17104,7 +17104,7 @@
                 </a:solidFill>
                 <a:latin typeface="Calibri"/>
               </a:rPr>
-              <a:t>note tranches</a:t>
+              <a:t>monthly tapes</a:t>
             </a:r>
           </a:p>
         </p:txBody>
@@ -17149,7 +17149,7 @@
                 </a:solidFill>
                 <a:latin typeface="Calibri"/>
               </a:rPr>
-              <a:t>Class A (AAA) / B / C, with sizes &amp; subordination</a:t>
+              <a:t>Jan 2024 – Apr 2026 ESMA history (Jan-2026 gap)</a:t>
             </a:r>
           </a:p>
         </p:txBody>
@@ -18123,7 +18123,7 @@
                 </a:solidFill>
                 <a:latin typeface="Calibri"/>
               </a:rPr>
-              <a:t>Built to scale to more data</a:t>
+              <a:t>Data-agnostic by design</a:t>
             </a:r>
           </a:p>
         </p:txBody>
@@ -18177,7 +18177,7 @@
                 </a:solidFill>
                 <a:latin typeface="Calibri"/>
               </a:rPr>
-              <a:t>Config-driven multi-deal registry — add a deal as a dict, no code change.</a:t>
+              <a:t>Add a deal via data/deals.json — no code change; Green-Lion defaults fill the gaps.</a:t>
             </a:r>
           </a:p>
           <a:p>
@@ -18208,7 +18208,7 @@
                 </a:solidFill>
                 <a:latin typeface="Calibri"/>
               </a:rPr>
-              <a:t>Durable cache: extract once, then instant; copes with 4yr of monthly tapes.</a:t>
+              <a:t>Proven over 27 months of monthly tapes (2024–2026), not a single snapshot.</a:t>
             </a:r>
           </a:p>
           <a:p>
@@ -18239,7 +18239,7 @@
                 </a:solidFill>
                 <a:latin typeface="Calibri"/>
               </a:rPr>
-              <a:t>Cache lifecycle hardened so a cold rebuild never serves stale results.</a:t>
+              <a:t>Durable cache: extract once, then instant; deal-context keys resolve per deal.</a:t>
             </a:r>
           </a:p>
         </p:txBody>

</xml_diff>

<commit_message>
docs: top up data-card, quickstart, and deck with parquet + deal-context keys
#177 (the #166 finalisation) merged before #175 (Epic A), so its docs/deck
could only describe the then-current main and omitted Epic A's features. Now
that #175 is merged, bring the remaining artifacts to parity:

- data-card.md: note format-agnostic ingestion (CSV or parquet, incl. the
  combined multi-month Overall_2024_2025_all_months.parquet sliced by reporting_date)
- quickstart.md: CSV/parquet tape loading; document all three optional
  deal-context keys (capital_structure, original_pool_balance, projection_base)
- presentation/build_deck.py: data-agnostic card now cites CSV/parquet + per-deal
  key resolution; regenerated LoanWhiz-Presentation.pptx

README was already brought to parity in the #175 reconcile. Follow-up to #166 / #175.

Co-Authored-By: Claude Opus 4.8 (1M context) <noreply@anthropic.com>
</commit_message>
<xml_diff>
--- a/presentation/LoanWhiz-Presentation.pptx
+++ b/presentation/LoanWhiz-Presentation.pptx
@@ -5290,7 +5290,7 @@
                 </a:solidFill>
                 <a:latin typeface="Calibri"/>
               </a:rPr>
-              <a:t> — Apache-2.0; add a deal via data/deals.json (no code change), add a primitive in a few lines.</a:t>
+              <a:t> — Apache-2.0; add a deal via data/deals.json (no code change), CSV or parquet tapes, add a primitive in a few lines.</a:t>
             </a:r>
           </a:p>
         </p:txBody>
@@ -18208,7 +18208,7 @@
                 </a:solidFill>
                 <a:latin typeface="Calibri"/>
               </a:rPr>
-              <a:t>Proven over 27 months of monthly tapes (2024–2026), not a single snapshot.</a:t>
+              <a:t>Format-agnostic tapes: CSV or parquet (incl. a combined multi-month file), 27 months proven.</a:t>
             </a:r>
           </a:p>
           <a:p>
@@ -18239,7 +18239,7 @@
                 </a:solidFill>
                 <a:latin typeface="Calibri"/>
               </a:rPr>
-              <a:t>Durable cache: extract once, then instant; deal-context keys resolve per deal.</a:t>
+              <a:t>Per-deal keys resolve from context (capital structure, pool balance, triggers); cached.</a:t>
             </a:r>
           </a:p>
         </p:txBody>

</xml_diff>

<commit_message>
docs(demo): honest deeploans-or-direct provenance; real-data MCP terminal; cards
Deck (loanwhiz-deck.json -> re-rendered pptx): provenance is now honest -- every
tape is tagged deeploans OR direct, selectable per deal; this demo runs direct
(the deeploans path is wired but its backend is not stood up here). Three cards
and the closing summary corrected from the prior "ingested through deeploans on
the live path" overclaim.

MCP terminal (demo/ + web/public/mcp-terminal.html): data_source shows
"direct (deeploans path wired)"; the covenant step now shows
reserve_fund_shortfall_trigger OK (100% funded), 3/3 in compliance, reflecting
the B4 fix. Waterfall step already consistent with the reconstructed ledger.

Add the demo card PNGs (white background, Waafir green/gold accents),
build_cards.py generator, the bundled demo video, and the library map.
</commit_message>
<xml_diff>
--- a/presentation/LoanWhiz-Presentation.pptx
+++ b/presentation/LoanWhiz-Presentation.pptx
@@ -14,9 +14,10 @@
     <p:sldId id="262" r:id="rId8"/>
     <p:sldId id="263" r:id="rId9"/>
     <p:sldId id="264" r:id="rId10"/>
+    <p:sldId id="265" r:id="rId11"/>
   </p:sldIdLst>
   <p:notesMasterIdLst>
-    <p:notesMasterId r:id="rId11"/>
+    <p:notesMasterId r:id="rId12"/>
   </p:notesMasterIdLst>
   <p:sldSz cx="12191695" cy="6858000"/>
   <p:notesSz cx="6858000" cy="12191695"/>
@@ -534,6 +535,94 @@
             <a:fld id="{F7021451-1387-4CA6-816F-3879F97B5CBC}" type="slidenum">
               <a:rPr lang="en-US"/>
               <a:t>1</a:t>
+            </a:fld>
+            <a:endParaRPr lang="en-US"/>
+          </a:p>
+        </p:txBody>
+      </p:sp>
+    </p:spTree>
+    <p:extLst>
+      <p:ext uri="{BB962C8B-B14F-4D97-AF65-F5344CB8AC3E}">
+        <p14:creationId xmlns:p14="http://schemas.microsoft.com/office/powerpoint/2010/main" val="1024086991"/>
+      </p:ext>
+    </p:extLst>
+  </p:cSld>
+  <p:clrMapOvr>
+    <a:masterClrMapping/>
+  </p:clrMapOvr>
+</p:notes>
+</file>
+
+<file path=ppt/notesSlides/notesSlide10.xml><?xml version="1.0" encoding="utf-8"?>
+<p:notes xmlns:a="http://schemas.openxmlformats.org/drawingml/2006/main" xmlns:r="http://schemas.openxmlformats.org/officeDocument/2006/relationships" xmlns:p="http://schemas.openxmlformats.org/presentationml/2006/main">
+  <p:cSld>
+    <p:spTree>
+      <p:nvGrpSpPr>
+        <p:cNvPr id="1" name=""/>
+        <p:cNvGrpSpPr/>
+        <p:nvPr/>
+      </p:nvGrpSpPr>
+      <p:grpSpPr>
+        <a:xfrm>
+          <a:off x="0" y="0"/>
+          <a:ext cx="0" cy="0"/>
+          <a:chOff x="0" y="0"/>
+          <a:chExt cx="0" cy="0"/>
+        </a:xfrm>
+      </p:grpSpPr>
+      <p:sp>
+        <p:nvSpPr>
+          <p:cNvPr id="2" name="Slide Image Placeholder 1"/>
+          <p:cNvSpPr>
+            <a:spLocks noGrp="1" noRot="1" noChangeAspect="1"/>
+          </p:cNvSpPr>
+          <p:nvPr>
+            <p:ph type="sldImg"/>
+          </p:nvPr>
+        </p:nvSpPr>
+        <p:spPr/>
+      </p:sp>
+      <p:sp>
+        <p:nvSpPr>
+          <p:cNvPr id="3" name="Notes Placeholder 2"/>
+          <p:cNvSpPr>
+            <a:spLocks noGrp="1"/>
+          </p:cNvSpPr>
+          <p:nvPr>
+            <p:ph type="body" idx="1"/>
+          </p:nvPr>
+        </p:nvSpPr>
+        <p:spPr/>
+        <p:txBody>
+          <a:bodyPr/>
+          <a:lstStyle/>
+          <a:p>
+            <a:r>
+              <a:rPr lang="en-US" dirty="0"/>
+              <a:t/>
+            </a:r>
+            <a:endParaRPr lang="en-US" dirty="0"/>
+          </a:p>
+        </p:txBody>
+      </p:sp>
+      <p:sp>
+        <p:nvSpPr>
+          <p:cNvPr id="4" name="Slide Number Placeholder 3"/>
+          <p:cNvSpPr>
+            <a:spLocks noGrp="1"/>
+          </p:cNvSpPr>
+          <p:nvPr>
+            <p:ph type="sldNum" sz="quarter" idx="10"/>
+          </p:nvPr>
+        </p:nvSpPr>
+        <p:spPr/>
+        <p:txBody>
+          <a:bodyPr/>
+          <a:lstStyle/>
+          <a:p>
+            <a:fld id="{F7021451-1387-4CA6-816F-3879F97B5CBC}" type="slidenum">
+              <a:rPr lang="en-US"/>
+              <a:t>10</a:t>
             </a:fld>
             <a:endParaRPr lang="en-US"/>
           </a:p>
@@ -2047,6 +2136,184 @@
 </p:sld>
 </file>
 
+<file path=ppt/slides/slide10.xml><?xml version="1.0" encoding="utf-8"?>
+<p:sld xmlns:a="http://schemas.openxmlformats.org/drawingml/2006/main" xmlns:r="http://schemas.openxmlformats.org/officeDocument/2006/relationships" xmlns:p="http://schemas.openxmlformats.org/presentationml/2006/main">
+  <p:cSld name="Slide 10">
+    <p:bg>
+      <p:bgPr>
+        <a:solidFill>
+          <a:srgbClr val="1B2A4A"/>
+        </a:solidFill>
+      </p:bgPr>
+    </p:bg>
+    <p:spTree>
+      <p:nvGrpSpPr>
+        <p:cNvPr id="1" name=""/>
+        <p:cNvGrpSpPr/>
+        <p:nvPr/>
+      </p:nvGrpSpPr>
+      <p:grpSpPr>
+        <a:xfrm>
+          <a:off x="0" y="0"/>
+          <a:ext cx="0" cy="0"/>
+          <a:chOff x="0" y="0"/>
+          <a:chExt cx="0" cy="0"/>
+        </a:xfrm>
+      </p:grpSpPr>
+      <p:sp>
+        <p:nvSpPr>
+          <p:cNvPr id="2" name="Shape 0"/>
+          <p:cNvSpPr/>
+          <p:nvPr/>
+        </p:nvSpPr>
+        <p:spPr>
+          <a:xfrm>
+            <a:off x="0" y="0"/>
+            <a:ext cx="164592" cy="6858000"/>
+          </a:xfrm>
+          <a:prstGeom prst="rect">
+            <a:avLst/>
+          </a:prstGeom>
+          <a:solidFill>
+            <a:srgbClr val="129E8F"/>
+          </a:solidFill>
+          <a:ln/>
+        </p:spPr>
+      </p:sp>
+      <p:sp>
+        <p:nvSpPr>
+          <p:cNvPr id="3" name="Text 1"/>
+          <p:cNvSpPr/>
+          <p:nvPr/>
+        </p:nvSpPr>
+        <p:spPr>
+          <a:xfrm>
+            <a:off x="868680" y="2468880"/>
+            <a:ext cx="10058400" cy="365760"/>
+          </a:xfrm>
+          <a:prstGeom prst="rect">
+            <a:avLst/>
+          </a:prstGeom>
+          <a:noFill/>
+          <a:ln/>
+        </p:spPr>
+        <p:txBody>
+          <a:bodyPr wrap="square" lIns="0" tIns="0" rIns="0" bIns="0" rtlCol="0" anchor="t"/>
+          <a:lstStyle/>
+          <a:p>
+            <a:pPr algn="l" indent="0" marL="0">
+              <a:lnSpc>
+                <a:spcPct val="100000"/>
+              </a:lnSpc>
+              <a:buNone/>
+            </a:pPr>
+            <a:r>
+              <a:rPr lang="en-US" sz="1300" b="1" dirty="0">
+                <a:solidFill>
+                  <a:srgbClr val="129E8F"/>
+                </a:solidFill>
+                <a:latin typeface="Calibri" pitchFamily="34" charset="0"/>
+                <a:ea typeface="Calibri" pitchFamily="34" charset="-122"/>
+                <a:cs typeface="Calibri" pitchFamily="34" charset="-120"/>
+              </a:rPr>
+              <a:t>WHY IT ANSWERS THE CHALLENGE</a:t>
+            </a:r>
+            <a:endParaRPr lang="en-US" sz="1300" dirty="0"/>
+          </a:p>
+        </p:txBody>
+      </p:sp>
+      <p:sp>
+        <p:nvSpPr>
+          <p:cNvPr id="4" name="Text 2"/>
+          <p:cNvSpPr/>
+          <p:nvPr/>
+        </p:nvSpPr>
+        <p:spPr>
+          <a:xfrm>
+            <a:off x="841248" y="2880360"/>
+            <a:ext cx="10424160" cy="1097280"/>
+          </a:xfrm>
+          <a:prstGeom prst="rect">
+            <a:avLst/>
+          </a:prstGeom>
+          <a:noFill/>
+          <a:ln/>
+        </p:spPr>
+        <p:txBody>
+          <a:bodyPr wrap="square" lIns="0" tIns="0" rIns="0" bIns="0" rtlCol="0" anchor="t"/>
+          <a:lstStyle/>
+          <a:p>
+            <a:pPr algn="l" indent="0" marL="0">
+              <a:lnSpc>
+                <a:spcPct val="100000"/>
+              </a:lnSpc>
+              <a:buNone/>
+            </a:pPr>
+            <a:r>
+              <a:rPr lang="en-US" sz="4000" b="1" dirty="0">
+                <a:solidFill>
+                  <a:srgbClr val="FFFFFF"/>
+                </a:solidFill>
+                <a:latin typeface="Calibri" pitchFamily="34" charset="0"/>
+                <a:ea typeface="Calibri" pitchFamily="34" charset="-122"/>
+                <a:cs typeface="Calibri" pitchFamily="34" charset="-120"/>
+              </a:rPr>
+              <a:t>Reusable, trustworthy, broadly applicable</a:t>
+            </a:r>
+            <a:endParaRPr lang="en-US" sz="4000" dirty="0"/>
+          </a:p>
+        </p:txBody>
+      </p:sp>
+      <p:sp>
+        <p:nvSpPr>
+          <p:cNvPr id="5" name="Text 3"/>
+          <p:cNvSpPr/>
+          <p:nvPr/>
+        </p:nvSpPr>
+        <p:spPr>
+          <a:xfrm>
+            <a:off x="868680" y="3977640"/>
+            <a:ext cx="9875520" cy="1097280"/>
+          </a:xfrm>
+          <a:prstGeom prst="rect">
+            <a:avLst/>
+          </a:prstGeom>
+          <a:noFill/>
+          <a:ln/>
+        </p:spPr>
+        <p:txBody>
+          <a:bodyPr wrap="square" lIns="0" tIns="0" rIns="0" bIns="0" rtlCol="0" anchor="t"/>
+          <a:lstStyle/>
+          <a:p>
+            <a:pPr algn="l" indent="0" marL="0">
+              <a:lnSpc>
+                <a:spcPct val="120000"/>
+              </a:lnSpc>
+              <a:buNone/>
+            </a:pPr>
+            <a:r>
+              <a:rPr lang="en-US" sz="1600" dirty="0">
+                <a:solidFill>
+                  <a:srgbClr val="C7D3E8"/>
+                </a:solidFill>
+                <a:latin typeface="Calibri" pitchFamily="34" charset="0"/>
+                <a:ea typeface="Calibri" pitchFamily="34" charset="-122"/>
+                <a:cs typeface="Calibri" pitchFamily="34" charset="-120"/>
+              </a:rPr>
+              <a:t>SF-native primitives + a registry, packaged as an MCP — not a one-off script. Validated to the cent against a real ING deal, demonstrated across Dutch, Italian and Spanish RMBS, with citations, governance and data-provenance on every output. Built on the organiser's own tools — deeploans wired as a selectable ingestion source (we run direct for this demo's infra), FINOS for governance — as real integration points, not name-drops. And honest about its limits — the capability matrix shows exactly what's proven.</a:t>
+            </a:r>
+            <a:endParaRPr lang="en-US" sz="1600" dirty="0"/>
+          </a:p>
+        </p:txBody>
+      </p:sp>
+    </p:spTree>
+  </p:cSld>
+  <p:clrMapOvr>
+    <a:masterClrMapping/>
+  </p:clrMapOvr>
+</p:sld>
+</file>
+
 <file path=ppt/slides/slide2.xml><?xml version="1.0" encoding="utf-8"?>
 <p:sld xmlns:a="http://schemas.openxmlformats.org/drawingml/2006/main" xmlns:r="http://schemas.openxmlformats.org/officeDocument/2006/relationships" xmlns:p="http://schemas.openxmlformats.org/presentationml/2006/main">
   <p:cSld name="Slide 2">
@@ -2332,7 +2599,7 @@
                 <a:ea typeface="Calibri" pitchFamily="34" charset="-122"/>
                 <a:cs typeface="Calibri" pitchFamily="34" charset="-120"/>
               </a:rPr>
-              <a:t>Three concerns a chatbot collapses into one. Read once, execute deterministically, orchestrate with an agent.</a:t>
+              <a:t>The deterministic-primitives + dynamic-orchestration hybrid the brief calls for: read once, execute deterministically, orchestrate with an agent — and keep the LLM out of the maths. We have the agent; we just don't let it do arithmetic.</a:t>
             </a:r>
             <a:endParaRPr lang="en-US" sz="1400" dirty="0"/>
           </a:p>
@@ -3122,7 +3389,7 @@
                 <a:ea typeface="Calibri" pitchFamily="34" charset="-122"/>
                 <a:cs typeface="Calibri" pitchFamily="34" charset="-120"/>
               </a:rPr>
-              <a:t>THE PROOF</a:t>
+              <a:t>THE DYNAMIC ORCHESTRATION LAYER</a:t>
             </a:r>
             <a:endParaRPr lang="en-US" sz="1200" dirty="0"/>
           </a:p>
@@ -3164,7 +3431,7 @@
                 <a:ea typeface="Calibri" pitchFamily="34" charset="-122"/>
                 <a:cs typeface="Calibri" pitchFamily="34" charset="-120"/>
               </a:rPr>
-              <a:t>Validated against a real ING deal — to the cent</a:t>
+              <a:t>The meta-agent loop the brief describes</a:t>
             </a:r>
             <a:endParaRPr lang="en-US" sz="2800" dirty="0"/>
           </a:p>
@@ -3327,7 +3594,7 @@
                 <a:ea typeface="Calibri" pitchFamily="34" charset="-122"/>
                 <a:cs typeface="Calibri" pitchFamily="34" charset="-120"/>
               </a:rPr>
-              <a:t>Green Lion 2024-1: our engine re-runs the deal's own published Notes &amp; Cash waterfall. No report distribution figures fed in — Class A interest is computed (balance × coupon × days/360).</a:t>
+              <a:t>Plan → compose → execute → validate → human-review → answer. The LangGraph agent decides which primitives to call; the primitives do the maths deterministically; governance gates the result.</a:t>
             </a:r>
             <a:endParaRPr lang="en-US" sz="1400" dirty="0"/>
           </a:p>
@@ -3342,11 +3609,11 @@
         <p:spPr>
           <a:xfrm>
             <a:off x="640080" y="2423160"/>
-            <a:ext cx="2583866" cy="1783080"/>
+            <a:ext cx="5364328" cy="1655064"/>
           </a:xfrm>
           <a:prstGeom prst="roundRect">
             <a:avLst>
-              <a:gd name="adj" fmla="val 2564"/>
+              <a:gd name="adj" fmla="val 2762"/>
             </a:avLst>
           </a:prstGeom>
           <a:solidFill>
@@ -3369,14 +3636,34 @@
       </p:sp>
       <p:sp>
         <p:nvSpPr>
-          <p:cNvPr id="10" name="Text 8"/>
-          <p:cNvSpPr/>
-          <p:nvPr/>
-        </p:nvSpPr>
-        <p:spPr>
-          <a:xfrm>
-            <a:off x="640080" y="2606040"/>
-            <a:ext cx="2583866" cy="777240"/>
+          <p:cNvPr id="10" name="Shape 8"/>
+          <p:cNvSpPr/>
+          <p:nvPr/>
+        </p:nvSpPr>
+        <p:spPr>
+          <a:xfrm>
+            <a:off x="640080" y="2423160"/>
+            <a:ext cx="82296" cy="1655064"/>
+          </a:xfrm>
+          <a:prstGeom prst="rect">
+            <a:avLst/>
+          </a:prstGeom>
+          <a:solidFill>
+            <a:srgbClr val="2B59D6"/>
+          </a:solidFill>
+          <a:ln/>
+        </p:spPr>
+      </p:sp>
+      <p:sp>
+        <p:nvSpPr>
+          <p:cNvPr id="11" name="Text 9"/>
+          <p:cNvSpPr/>
+          <p:nvPr/>
+        </p:nvSpPr>
+        <p:spPr>
+          <a:xfrm>
+            <a:off x="896112" y="2624328"/>
+            <a:ext cx="4907128" cy="365760"/>
           </a:xfrm>
           <a:prstGeom prst="rect">
             <a:avLst/>
@@ -3388,37 +3675,37 @@
           <a:bodyPr wrap="square" lIns="0" tIns="0" rIns="0" bIns="0" rtlCol="0" anchor="t"/>
           <a:lstStyle/>
           <a:p>
-            <a:pPr algn="ctr" indent="0" marL="0">
+            <a:pPr algn="l" indent="0" marL="0">
               <a:lnSpc>
                 <a:spcPct val="100000"/>
               </a:lnSpc>
               <a:buNone/>
             </a:pPr>
             <a:r>
-              <a:rPr lang="en-US" sz="4200" b="1" dirty="0">
-                <a:solidFill>
-                  <a:srgbClr val="2B59D6"/>
-                </a:solidFill>
-                <a:latin typeface="Calibri" pitchFamily="34" charset="0"/>
-                <a:ea typeface="Calibri" pitchFamily="34" charset="-122"/>
-                <a:cs typeface="Calibri" pitchFamily="34" charset="-120"/>
-              </a:rPr>
-              <a:t>11/11</a:t>
-            </a:r>
-            <a:endParaRPr lang="en-US" sz="4200" dirty="0"/>
-          </a:p>
-        </p:txBody>
-      </p:sp>
-      <p:sp>
-        <p:nvSpPr>
-          <p:cNvPr id="11" name="Text 9"/>
-          <p:cNvSpPr/>
-          <p:nvPr/>
-        </p:nvSpPr>
-        <p:spPr>
-          <a:xfrm>
-            <a:off x="640080" y="3383280"/>
-            <a:ext cx="2583866" cy="320040"/>
+              <a:rPr lang="en-US" sz="1500" b="1" dirty="0">
+                <a:solidFill>
+                  <a:srgbClr val="1B2A4A"/>
+                </a:solidFill>
+                <a:latin typeface="Calibri" pitchFamily="34" charset="0"/>
+                <a:ea typeface="Calibri" pitchFamily="34" charset="-122"/>
+                <a:cs typeface="Calibri" pitchFamily="34" charset="-120"/>
+              </a:rPr>
+              <a:t>1 · Plan &amp; decompose</a:t>
+            </a:r>
+            <a:endParaRPr lang="en-US" sz="1500" dirty="0"/>
+          </a:p>
+        </p:txBody>
+      </p:sp>
+      <p:sp>
+        <p:nvSpPr>
+          <p:cNvPr id="12" name="Text 10"/>
+          <p:cNvSpPr/>
+          <p:nvPr/>
+        </p:nvSpPr>
+        <p:spPr>
+          <a:xfrm>
+            <a:off x="896112" y="3044952"/>
+            <a:ext cx="4861408" cy="923544"/>
           </a:xfrm>
           <a:prstGeom prst="rect">
             <a:avLst/>
@@ -3430,56 +3717,17 @@
           <a:bodyPr wrap="square" lIns="0" tIns="0" rIns="0" bIns="0" rtlCol="0" anchor="t"/>
           <a:lstStyle/>
           <a:p>
-            <a:pPr algn="ctr" indent="0" marL="0">
-              <a:lnSpc>
-                <a:spcPct val="100000"/>
-              </a:lnSpc>
-              <a:buNone/>
-            </a:pPr>
-            <a:r>
-              <a:rPr lang="en-US" sz="1400" b="1" dirty="0">
-                <a:solidFill>
-                  <a:srgbClr val="1B2A4A"/>
-                </a:solidFill>
-                <a:latin typeface="Calibri" pitchFamily="34" charset="0"/>
-                <a:ea typeface="Calibri" pitchFamily="34" charset="-122"/>
-                <a:cs typeface="Calibri" pitchFamily="34" charset="-120"/>
-              </a:rPr>
-              <a:t>revenue PoP steps</a:t>
-            </a:r>
-            <a:endParaRPr lang="en-US" sz="1400" dirty="0"/>
-          </a:p>
-        </p:txBody>
-      </p:sp>
-      <p:sp>
-        <p:nvSpPr>
-          <p:cNvPr id="12" name="Text 10"/>
-          <p:cNvSpPr/>
-          <p:nvPr/>
-        </p:nvSpPr>
-        <p:spPr>
-          <a:xfrm>
-            <a:off x="804672" y="3703320"/>
-            <a:ext cx="2254682" cy="411480"/>
-          </a:xfrm>
-          <a:prstGeom prst="rect">
-            <a:avLst/>
-          </a:prstGeom>
-          <a:noFill/>
-          <a:ln/>
-        </p:spPr>
-        <p:txBody>
-          <a:bodyPr wrap="square" lIns="0" tIns="0" rIns="0" bIns="0" rtlCol="0" anchor="t"/>
-          <a:lstStyle/>
-          <a:p>
-            <a:pPr algn="ctr" indent="0" marL="0">
-              <a:lnSpc>
-                <a:spcPct val="100000"/>
-              </a:lnSpc>
-              <a:buNone/>
-            </a:pPr>
-            <a:r>
-              <a:rPr lang="en-US" sz="1000" dirty="0">
+            <a:pPr algn="l" indent="0" marL="0">
+              <a:lnSpc>
+                <a:spcPct val="106000"/>
+              </a:lnSpc>
+              <a:spcAft>
+                <a:spcPts val="300"/>
+              </a:spcAft>
+              <a:buNone/>
+            </a:pPr>
+            <a:r>
+              <a:rPr lang="en-US" sz="1250" dirty="0">
                 <a:solidFill>
                   <a:srgbClr val="536177"/>
                 </a:solidFill>
@@ -3487,9 +3735,9 @@
                 <a:ea typeface="Calibri" pitchFamily="34" charset="-122"/>
                 <a:cs typeface="Calibri" pitchFamily="34" charset="-120"/>
               </a:rPr>
-              <a:t>reconciled to the cent</a:t>
-            </a:r>
-            <a:endParaRPr lang="en-US" sz="1000" dirty="0"/>
+              <a:t>The planner breaks the question into primitive subtasks and orders them as a DAG — which tape, which deal model, which waterfall.</a:t>
+            </a:r>
+            <a:endParaRPr lang="en-US" sz="1250" dirty="0"/>
           </a:p>
         </p:txBody>
       </p:sp>
@@ -3501,12 +3749,12 @@
         </p:nvSpPr>
         <p:spPr>
           <a:xfrm>
-            <a:off x="3415970" y="2423160"/>
-            <a:ext cx="2583866" cy="1783080"/>
+            <a:off x="6187288" y="2423160"/>
+            <a:ext cx="5364328" cy="1655064"/>
           </a:xfrm>
           <a:prstGeom prst="roundRect">
             <a:avLst>
-              <a:gd name="adj" fmla="val 2564"/>
+              <a:gd name="adj" fmla="val 2762"/>
             </a:avLst>
           </a:prstGeom>
           <a:solidFill>
@@ -3529,14 +3777,34 @@
       </p:sp>
       <p:sp>
         <p:nvSpPr>
-          <p:cNvPr id="14" name="Text 12"/>
-          <p:cNvSpPr/>
-          <p:nvPr/>
-        </p:nvSpPr>
-        <p:spPr>
-          <a:xfrm>
-            <a:off x="3415970" y="2606040"/>
-            <a:ext cx="2583866" cy="777240"/>
+          <p:cNvPr id="14" name="Shape 12"/>
+          <p:cNvSpPr/>
+          <p:nvPr/>
+        </p:nvSpPr>
+        <p:spPr>
+          <a:xfrm>
+            <a:off x="6187288" y="2423160"/>
+            <a:ext cx="82296" cy="1655064"/>
+          </a:xfrm>
+          <a:prstGeom prst="rect">
+            <a:avLst/>
+          </a:prstGeom>
+          <a:solidFill>
+            <a:srgbClr val="129E8F"/>
+          </a:solidFill>
+          <a:ln/>
+        </p:spPr>
+      </p:sp>
+      <p:sp>
+        <p:nvSpPr>
+          <p:cNvPr id="15" name="Text 13"/>
+          <p:cNvSpPr/>
+          <p:nvPr/>
+        </p:nvSpPr>
+        <p:spPr>
+          <a:xfrm>
+            <a:off x="6443320" y="2624328"/>
+            <a:ext cx="4907128" cy="365760"/>
           </a:xfrm>
           <a:prstGeom prst="rect">
             <a:avLst/>
@@ -3548,37 +3816,37 @@
           <a:bodyPr wrap="square" lIns="0" tIns="0" rIns="0" bIns="0" rtlCol="0" anchor="t"/>
           <a:lstStyle/>
           <a:p>
-            <a:pPr algn="ctr" indent="0" marL="0">
+            <a:pPr algn="l" indent="0" marL="0">
               <a:lnSpc>
                 <a:spcPct val="100000"/>
               </a:lnSpc>
               <a:buNone/>
             </a:pPr>
             <a:r>
-              <a:rPr lang="en-US" sz="4200" b="1" dirty="0">
-                <a:solidFill>
-                  <a:srgbClr val="2B59D6"/>
-                </a:solidFill>
-                <a:latin typeface="Calibri" pitchFamily="34" charset="0"/>
-                <a:ea typeface="Calibri" pitchFamily="34" charset="-122"/>
-                <a:cs typeface="Calibri" pitchFamily="34" charset="-120"/>
-              </a:rPr>
-              <a:t>4/4</a:t>
-            </a:r>
-            <a:endParaRPr lang="en-US" sz="4200" dirty="0"/>
-          </a:p>
-        </p:txBody>
-      </p:sp>
-      <p:sp>
-        <p:nvSpPr>
-          <p:cNvPr id="15" name="Text 13"/>
-          <p:cNvSpPr/>
-          <p:nvPr/>
-        </p:nvSpPr>
-        <p:spPr>
-          <a:xfrm>
-            <a:off x="3415970" y="3383280"/>
-            <a:ext cx="2583866" cy="320040"/>
+              <a:rPr lang="en-US" sz="1500" b="1" dirty="0">
+                <a:solidFill>
+                  <a:srgbClr val="1B2A4A"/>
+                </a:solidFill>
+                <a:latin typeface="Calibri" pitchFamily="34" charset="0"/>
+                <a:ea typeface="Calibri" pitchFamily="34" charset="-122"/>
+                <a:cs typeface="Calibri" pitchFamily="34" charset="-120"/>
+              </a:rPr>
+              <a:t>2 · Execute primitives</a:t>
+            </a:r>
+            <a:endParaRPr lang="en-US" sz="1500" dirty="0"/>
+          </a:p>
+        </p:txBody>
+      </p:sp>
+      <p:sp>
+        <p:nvSpPr>
+          <p:cNvPr id="16" name="Text 14"/>
+          <p:cNvSpPr/>
+          <p:nvPr/>
+        </p:nvSpPr>
+        <p:spPr>
+          <a:xfrm>
+            <a:off x="6443320" y="3044952"/>
+            <a:ext cx="4861408" cy="923544"/>
           </a:xfrm>
           <a:prstGeom prst="rect">
             <a:avLst/>
@@ -3590,56 +3858,17 @@
           <a:bodyPr wrap="square" lIns="0" tIns="0" rIns="0" bIns="0" rtlCol="0" anchor="t"/>
           <a:lstStyle/>
           <a:p>
-            <a:pPr algn="ctr" indent="0" marL="0">
-              <a:lnSpc>
-                <a:spcPct val="100000"/>
-              </a:lnSpc>
-              <a:buNone/>
-            </a:pPr>
-            <a:r>
-              <a:rPr lang="en-US" sz="1400" b="1" dirty="0">
-                <a:solidFill>
-                  <a:srgbClr val="1B2A4A"/>
-                </a:solidFill>
-                <a:latin typeface="Calibri" pitchFamily="34" charset="0"/>
-                <a:ea typeface="Calibri" pitchFamily="34" charset="-122"/>
-                <a:cs typeface="Calibri" pitchFamily="34" charset="-120"/>
-              </a:rPr>
-              <a:t>redemption steps</a:t>
-            </a:r>
-            <a:endParaRPr lang="en-US" sz="1400" dirty="0"/>
-          </a:p>
-        </p:txBody>
-      </p:sp>
-      <p:sp>
-        <p:nvSpPr>
-          <p:cNvPr id="16" name="Text 14"/>
-          <p:cNvSpPr/>
-          <p:nvPr/>
-        </p:nvSpPr>
-        <p:spPr>
-          <a:xfrm>
-            <a:off x="3580562" y="3703320"/>
-            <a:ext cx="2254682" cy="411480"/>
-          </a:xfrm>
-          <a:prstGeom prst="rect">
-            <a:avLst/>
-          </a:prstGeom>
-          <a:noFill/>
-          <a:ln/>
-        </p:spPr>
-        <p:txBody>
-          <a:bodyPr wrap="square" lIns="0" tIns="0" rIns="0" bIns="0" rtlCol="0" anchor="t"/>
-          <a:lstStyle/>
-          <a:p>
-            <a:pPr algn="ctr" indent="0" marL="0">
-              <a:lnSpc>
-                <a:spcPct val="100000"/>
-              </a:lnSpc>
-              <a:buNone/>
-            </a:pPr>
-            <a:r>
-              <a:rPr lang="en-US" sz="1000" dirty="0">
+            <a:pPr algn="l" indent="0" marL="0">
+              <a:lnSpc>
+                <a:spcPct val="106000"/>
+              </a:lnSpc>
+              <a:spcAft>
+                <a:spcPts val="300"/>
+              </a:spcAft>
+              <a:buNone/>
+            </a:pPr>
+            <a:r>
+              <a:rPr lang="en-US" sz="1250" dirty="0">
                 <a:solidFill>
                   <a:srgbClr val="536177"/>
                 </a:solidFill>
@@ -3647,9 +3876,9 @@
                 <a:ea typeface="Calibri" pitchFamily="34" charset="-122"/>
                 <a:cs typeface="Calibri" pitchFamily="34" charset="-120"/>
               </a:rPr>
-              <a:t>to the cent</a:t>
-            </a:r>
-            <a:endParaRPr lang="en-US" sz="1000" dirty="0"/>
+              <a:t>Typed SF primitives run the computation. Numbers are computed, not generated — the agent orchestrates, it never does arithmetic.</a:t>
+            </a:r>
+            <a:endParaRPr lang="en-US" sz="1250" dirty="0"/>
           </a:p>
         </p:txBody>
       </p:sp>
@@ -3661,12 +3890,12 @@
         </p:nvSpPr>
         <p:spPr>
           <a:xfrm>
-            <a:off x="6191860" y="2423160"/>
-            <a:ext cx="2583866" cy="1783080"/>
+            <a:off x="640080" y="4242816"/>
+            <a:ext cx="5364328" cy="1655064"/>
           </a:xfrm>
           <a:prstGeom prst="roundRect">
             <a:avLst>
-              <a:gd name="adj" fmla="val 2564"/>
+              <a:gd name="adj" fmla="val 2762"/>
             </a:avLst>
           </a:prstGeom>
           <a:solidFill>
@@ -3689,14 +3918,34 @@
       </p:sp>
       <p:sp>
         <p:nvSpPr>
-          <p:cNvPr id="18" name="Text 16"/>
-          <p:cNvSpPr/>
-          <p:nvPr/>
-        </p:nvSpPr>
-        <p:spPr>
-          <a:xfrm>
-            <a:off x="6191860" y="2606040"/>
-            <a:ext cx="2583866" cy="777240"/>
+          <p:cNvPr id="18" name="Shape 16"/>
+          <p:cNvSpPr/>
+          <p:nvPr/>
+        </p:nvSpPr>
+        <p:spPr>
+          <a:xfrm>
+            <a:off x="640080" y="4242816"/>
+            <a:ext cx="82296" cy="1655064"/>
+          </a:xfrm>
+          <a:prstGeom prst="rect">
+            <a:avLst/>
+          </a:prstGeom>
+          <a:solidFill>
+            <a:srgbClr val="1B2A4A"/>
+          </a:solidFill>
+          <a:ln/>
+        </p:spPr>
+      </p:sp>
+      <p:sp>
+        <p:nvSpPr>
+          <p:cNvPr id="19" name="Text 17"/>
+          <p:cNvSpPr/>
+          <p:nvPr/>
+        </p:nvSpPr>
+        <p:spPr>
+          <a:xfrm>
+            <a:off x="896112" y="4443984"/>
+            <a:ext cx="4907128" cy="365760"/>
           </a:xfrm>
           <a:prstGeom prst="rect">
             <a:avLst/>
@@ -3708,37 +3957,37 @@
           <a:bodyPr wrap="square" lIns="0" tIns="0" rIns="0" bIns="0" rtlCol="0" anchor="t"/>
           <a:lstStyle/>
           <a:p>
-            <a:pPr algn="ctr" indent="0" marL="0">
+            <a:pPr algn="l" indent="0" marL="0">
               <a:lnSpc>
                 <a:spcPct val="100000"/>
               </a:lnSpc>
               <a:buNone/>
             </a:pPr>
             <a:r>
-              <a:rPr lang="en-US" sz="4200" b="1" dirty="0">
-                <a:solidFill>
-                  <a:srgbClr val="2B59D6"/>
-                </a:solidFill>
-                <a:latin typeface="Calibri" pitchFamily="34" charset="0"/>
-                <a:ea typeface="Calibri" pitchFamily="34" charset="-122"/>
-                <a:cs typeface="Calibri" pitchFamily="34" charset="-120"/>
-              </a:rPr>
-              <a:t>€0.00</a:t>
-            </a:r>
-            <a:endParaRPr lang="en-US" sz="4200" dirty="0"/>
-          </a:p>
-        </p:txBody>
-      </p:sp>
-      <p:sp>
-        <p:nvSpPr>
-          <p:cNvPr id="19" name="Text 17"/>
-          <p:cNvSpPr/>
-          <p:nvPr/>
-        </p:nvSpPr>
-        <p:spPr>
-          <a:xfrm>
-            <a:off x="6191860" y="3383280"/>
-            <a:ext cx="2583866" cy="320040"/>
+              <a:rPr lang="en-US" sz="1500" b="1" dirty="0">
+                <a:solidFill>
+                  <a:srgbClr val="1B2A4A"/>
+                </a:solidFill>
+                <a:latin typeface="Calibri" pitchFamily="34" charset="0"/>
+                <a:ea typeface="Calibri" pitchFamily="34" charset="-122"/>
+                <a:cs typeface="Calibri" pitchFamily="34" charset="-120"/>
+              </a:rPr>
+              <a:t>3 · Validate &amp; gate</a:t>
+            </a:r>
+            <a:endParaRPr lang="en-US" sz="1500" dirty="0"/>
+          </a:p>
+        </p:txBody>
+      </p:sp>
+      <p:sp>
+        <p:nvSpPr>
+          <p:cNvPr id="20" name="Text 18"/>
+          <p:cNvSpPr/>
+          <p:nvPr/>
+        </p:nvSpPr>
+        <p:spPr>
+          <a:xfrm>
+            <a:off x="896112" y="4864608"/>
+            <a:ext cx="4861408" cy="923544"/>
           </a:xfrm>
           <a:prstGeom prst="rect">
             <a:avLst/>
@@ -3750,56 +3999,17 @@
           <a:bodyPr wrap="square" lIns="0" tIns="0" rIns="0" bIns="0" rtlCol="0" anchor="t"/>
           <a:lstStyle/>
           <a:p>
-            <a:pPr algn="ctr" indent="0" marL="0">
-              <a:lnSpc>
-                <a:spcPct val="100000"/>
-              </a:lnSpc>
-              <a:buNone/>
-            </a:pPr>
-            <a:r>
-              <a:rPr lang="en-US" sz="1400" b="1" dirty="0">
-                <a:solidFill>
-                  <a:srgbClr val="1B2A4A"/>
-                </a:solidFill>
-                <a:latin typeface="Calibri" pitchFamily="34" charset="0"/>
-                <a:ea typeface="Calibri" pitchFamily="34" charset="-122"/>
-                <a:cs typeface="Calibri" pitchFamily="34" charset="-120"/>
-              </a:rPr>
-              <a:t>reconciliation gap</a:t>
-            </a:r>
-            <a:endParaRPr lang="en-US" sz="1400" dirty="0"/>
-          </a:p>
-        </p:txBody>
-      </p:sp>
-      <p:sp>
-        <p:nvSpPr>
-          <p:cNvPr id="20" name="Text 18"/>
-          <p:cNvSpPr/>
-          <p:nvPr/>
-        </p:nvSpPr>
-        <p:spPr>
-          <a:xfrm>
-            <a:off x="6356452" y="3703320"/>
-            <a:ext cx="2254682" cy="411480"/>
-          </a:xfrm>
-          <a:prstGeom prst="rect">
-            <a:avLst/>
-          </a:prstGeom>
-          <a:noFill/>
-          <a:ln/>
-        </p:spPr>
-        <p:txBody>
-          <a:bodyPr wrap="square" lIns="0" tIns="0" rIns="0" bIns="0" rtlCol="0" anchor="t"/>
-          <a:lstStyle/>
-          <a:p>
-            <a:pPr algn="ctr" indent="0" marL="0">
-              <a:lnSpc>
-                <a:spcPct val="100000"/>
-              </a:lnSpc>
-              <a:buNone/>
-            </a:pPr>
-            <a:r>
-              <a:rPr lang="en-US" sz="1000" dirty="0">
+            <a:pPr algn="l" indent="0" marL="0">
+              <a:lnSpc>
+                <a:spcPct val="106000"/>
+              </a:lnSpc>
+              <a:spcAft>
+                <a:spcPts val="300"/>
+              </a:spcAft>
+              <a:buNone/>
+            </a:pPr>
+            <a:r>
+              <a:rPr lang="en-US" sz="1250" dirty="0">
                 <a:solidFill>
                   <a:srgbClr val="536177"/>
                 </a:solidFill>
@@ -3807,9 +4017,9 @@
                 <a:ea typeface="Calibri" pitchFamily="34" charset="-122"/>
                 <a:cs typeface="Calibri" pitchFamily="34" charset="-120"/>
               </a:rPr>
-              <a:t>the report's own €0.69 rounding modelled, not fudged</a:t>
-            </a:r>
-            <a:endParaRPr lang="en-US" sz="1000" dirty="0"/>
+              <a:t>Each output is validated and confidence-scored; below threshold is flagged retry-eligible and routed to human review before it can be used.</a:t>
+            </a:r>
+            <a:endParaRPr lang="en-US" sz="1250" dirty="0"/>
           </a:p>
         </p:txBody>
       </p:sp>
@@ -3821,12 +4031,12 @@
         </p:nvSpPr>
         <p:spPr>
           <a:xfrm>
-            <a:off x="8967749" y="2423160"/>
-            <a:ext cx="2583866" cy="1783080"/>
+            <a:off x="6187288" y="4242816"/>
+            <a:ext cx="5364328" cy="1655064"/>
           </a:xfrm>
           <a:prstGeom prst="roundRect">
             <a:avLst>
-              <a:gd name="adj" fmla="val 2564"/>
+              <a:gd name="adj" fmla="val 2762"/>
             </a:avLst>
           </a:prstGeom>
           <a:solidFill>
@@ -3849,14 +4059,34 @@
       </p:sp>
       <p:sp>
         <p:nvSpPr>
-          <p:cNvPr id="22" name="Text 20"/>
-          <p:cNvSpPr/>
-          <p:nvPr/>
-        </p:nvSpPr>
-        <p:spPr>
-          <a:xfrm>
-            <a:off x="8967749" y="2606040"/>
-            <a:ext cx="2583866" cy="777240"/>
+          <p:cNvPr id="22" name="Shape 20"/>
+          <p:cNvSpPr/>
+          <p:nvPr/>
+        </p:nvSpPr>
+        <p:spPr>
+          <a:xfrm>
+            <a:off x="6187288" y="4242816"/>
+            <a:ext cx="82296" cy="1655064"/>
+          </a:xfrm>
+          <a:prstGeom prst="rect">
+            <a:avLst/>
+          </a:prstGeom>
+          <a:solidFill>
+            <a:srgbClr val="2B59D6"/>
+          </a:solidFill>
+          <a:ln/>
+        </p:spPr>
+      </p:sp>
+      <p:sp>
+        <p:nvSpPr>
+          <p:cNvPr id="23" name="Text 21"/>
+          <p:cNvSpPr/>
+          <p:nvPr/>
+        </p:nvSpPr>
+        <p:spPr>
+          <a:xfrm>
+            <a:off x="6443320" y="4443984"/>
+            <a:ext cx="4907128" cy="365760"/>
           </a:xfrm>
           <a:prstGeom prst="rect">
             <a:avLst/>
@@ -3868,37 +4098,37 @@
           <a:bodyPr wrap="square" lIns="0" tIns="0" rIns="0" bIns="0" rtlCol="0" anchor="t"/>
           <a:lstStyle/>
           <a:p>
-            <a:pPr algn="ctr" indent="0" marL="0">
+            <a:pPr algn="l" indent="0" marL="0">
               <a:lnSpc>
                 <a:spcPct val="100000"/>
               </a:lnSpc>
               <a:buNone/>
             </a:pPr>
             <a:r>
-              <a:rPr lang="en-US" sz="4200" b="1" dirty="0">
-                <a:solidFill>
-                  <a:srgbClr val="2B59D6"/>
-                </a:solidFill>
-                <a:latin typeface="Calibri" pitchFamily="34" charset="0"/>
-                <a:ea typeface="Calibri" pitchFamily="34" charset="-122"/>
-                <a:cs typeface="Calibri" pitchFamily="34" charset="-120"/>
-              </a:rPr>
-              <a:t>1</a:t>
-            </a:r>
-            <a:endParaRPr lang="en-US" sz="4200" dirty="0"/>
-          </a:p>
-        </p:txBody>
-      </p:sp>
-      <p:sp>
-        <p:nvSpPr>
-          <p:cNvPr id="23" name="Text 21"/>
-          <p:cNvSpPr/>
-          <p:nvPr/>
-        </p:nvSpPr>
-        <p:spPr>
-          <a:xfrm>
-            <a:off x="8967749" y="3383280"/>
-            <a:ext cx="2583866" cy="320040"/>
+              <a:rPr lang="en-US" sz="1500" b="1" dirty="0">
+                <a:solidFill>
+                  <a:srgbClr val="1B2A4A"/>
+                </a:solidFill>
+                <a:latin typeface="Calibri" pitchFamily="34" charset="0"/>
+                <a:ea typeface="Calibri" pitchFamily="34" charset="-122"/>
+                <a:cs typeface="Calibri" pitchFamily="34" charset="-120"/>
+              </a:rPr>
+              <a:t>4 · Govern &amp; answer</a:t>
+            </a:r>
+            <a:endParaRPr lang="en-US" sz="1500" dirty="0"/>
+          </a:p>
+        </p:txBody>
+      </p:sp>
+      <p:sp>
+        <p:nvSpPr>
+          <p:cNvPr id="24" name="Text 22"/>
+          <p:cNvSpPr/>
+          <p:nvPr/>
+        </p:nvSpPr>
+        <p:spPr>
+          <a:xfrm>
+            <a:off x="6443320" y="4864608"/>
+            <a:ext cx="4861408" cy="923544"/>
           </a:xfrm>
           <a:prstGeom prst="rect">
             <a:avLst/>
@@ -3910,66 +4140,69 @@
           <a:bodyPr wrap="square" lIns="0" tIns="0" rIns="0" bIns="0" rtlCol="0" anchor="t"/>
           <a:lstStyle/>
           <a:p>
-            <a:pPr algn="ctr" indent="0" marL="0">
+            <a:pPr algn="l" indent="0" marL="0">
+              <a:lnSpc>
+                <a:spcPct val="106000"/>
+              </a:lnSpc>
+              <a:spcAft>
+                <a:spcPts val="300"/>
+              </a:spcAft>
+              <a:buNone/>
+            </a:pPr>
+            <a:r>
+              <a:rPr lang="en-US" sz="1250" dirty="0">
+                <a:solidFill>
+                  <a:srgbClr val="536177"/>
+                </a:solidFill>
+                <a:latin typeface="Calibri" pitchFamily="34" charset="0"/>
+                <a:ea typeface="Calibri" pitchFamily="34" charset="-122"/>
+                <a:cs typeface="Calibri" pitchFamily="34" charset="-120"/>
+              </a:rPr>
+              <a:t>Min-confidence aggregated, citations deduplicated, an audit entry written — then a grounded answer with its evidence pack is returned.</a:t>
+            </a:r>
+            <a:endParaRPr lang="en-US" sz="1250" dirty="0"/>
+          </a:p>
+        </p:txBody>
+      </p:sp>
+      <p:sp>
+        <p:nvSpPr>
+          <p:cNvPr id="25" name="Text 23"/>
+          <p:cNvSpPr/>
+          <p:nvPr/>
+        </p:nvSpPr>
+        <p:spPr>
+          <a:xfrm>
+            <a:off x="640080" y="5989320"/>
+            <a:ext cx="10911535" cy="365760"/>
+          </a:xfrm>
+          <a:prstGeom prst="rect">
+            <a:avLst/>
+          </a:prstGeom>
+          <a:noFill/>
+          <a:ln/>
+        </p:spPr>
+        <p:txBody>
+          <a:bodyPr wrap="square" lIns="0" tIns="0" rIns="0" bIns="0" rtlCol="0" anchor="t"/>
+          <a:lstStyle/>
+          <a:p>
+            <a:pPr algn="l" indent="0" marL="0">
               <a:lnSpc>
                 <a:spcPct val="100000"/>
               </a:lnSpc>
               <a:buNone/>
             </a:pPr>
             <a:r>
-              <a:rPr lang="en-US" sz="1400" b="1" dirty="0">
-                <a:solidFill>
-                  <a:srgbClr val="1B2A4A"/>
-                </a:solidFill>
-                <a:latin typeface="Calibri" pitchFamily="34" charset="0"/>
-                <a:ea typeface="Calibri" pitchFamily="34" charset="-122"/>
-                <a:cs typeface="Calibri" pitchFamily="34" charset="-120"/>
-              </a:rPr>
-              <a:t>real ING deal</a:t>
-            </a:r>
-            <a:endParaRPr lang="en-US" sz="1400" dirty="0"/>
-          </a:p>
-        </p:txBody>
-      </p:sp>
-      <p:sp>
-        <p:nvSpPr>
-          <p:cNvPr id="24" name="Text 22"/>
-          <p:cNvSpPr/>
-          <p:nvPr/>
-        </p:nvSpPr>
-        <p:spPr>
-          <a:xfrm>
-            <a:off x="9132341" y="3703320"/>
-            <a:ext cx="2254682" cy="411480"/>
-          </a:xfrm>
-          <a:prstGeom prst="rect">
-            <a:avLst/>
-          </a:prstGeom>
-          <a:noFill/>
-          <a:ln/>
-        </p:spPr>
-        <p:txBody>
-          <a:bodyPr wrap="square" lIns="0" tIns="0" rIns="0" bIns="0" rtlCol="0" anchor="t"/>
-          <a:lstStyle/>
-          <a:p>
-            <a:pPr algn="ctr" indent="0" marL="0">
-              <a:lnSpc>
-                <a:spcPct val="100000"/>
-              </a:lnSpc>
-              <a:buNone/>
-            </a:pPr>
-            <a:r>
-              <a:rPr lang="en-US" sz="1000" dirty="0">
-                <a:solidFill>
-                  <a:srgbClr val="536177"/>
-                </a:solidFill>
-                <a:latin typeface="Calibri" pitchFamily="34" charset="0"/>
-                <a:ea typeface="Calibri" pitchFamily="34" charset="-122"/>
-                <a:cs typeface="Calibri" pitchFamily="34" charset="-120"/>
-              </a:rPr>
-              <a:t>its own published quarterly report</a:t>
-            </a:r>
-            <a:endParaRPr lang="en-US" sz="1000" dirty="0"/>
+              <a:rPr lang="en-US" sz="1200" i="1" dirty="0">
+                <a:solidFill>
+                  <a:srgbClr val="6B7A90"/>
+                </a:solidFill>
+                <a:latin typeface="Calibri" pitchFamily="34" charset="0"/>
+                <a:ea typeface="Calibri" pitchFamily="34" charset="-122"/>
+                <a:cs typeface="Calibri" pitchFamily="34" charset="-120"/>
+              </a:rPr>
+              <a:t>Human-review routing is live; the validator-driven auto-retry is a documented hook, not yet a live re-invocation loop.</a:t>
+            </a:r>
+            <a:endParaRPr lang="en-US" sz="1200" dirty="0"/>
           </a:p>
         </p:txBody>
       </p:sp>
@@ -4061,7 +4294,7 @@
                 <a:ea typeface="Calibri" pitchFamily="34" charset="-122"/>
                 <a:cs typeface="Calibri" pitchFamily="34" charset="-120"/>
               </a:rPr>
-              <a:t>BROADLY APPLICABLE — NOT HARDCODED</a:t>
+              <a:t>THE PROOF</a:t>
             </a:r>
             <a:endParaRPr lang="en-US" sz="1200" dirty="0"/>
           </a:p>
@@ -4103,7 +4336,7 @@
                 <a:ea typeface="Calibri" pitchFamily="34" charset="-122"/>
                 <a:cs typeface="Calibri" pitchFamily="34" charset="-120"/>
               </a:rPr>
-              <a:t>The same primitives across three jurisdictions</a:t>
+              <a:t>Validated against a real ING deal — to the cent</a:t>
             </a:r>
             <a:endParaRPr lang="en-US" sz="2800" dirty="0"/>
           </a:p>
@@ -4230,9 +4463,948 @@
           </a:p>
         </p:txBody>
       </p:sp>
+      <p:sp>
+        <p:nvSpPr>
+          <p:cNvPr id="8" name="Text 6"/>
+          <p:cNvSpPr/>
+          <p:nvPr/>
+        </p:nvSpPr>
+        <p:spPr>
+          <a:xfrm>
+            <a:off x="640080" y="1572768"/>
+            <a:ext cx="10911535" cy="640080"/>
+          </a:xfrm>
+          <a:prstGeom prst="rect">
+            <a:avLst/>
+          </a:prstGeom>
+          <a:noFill/>
+          <a:ln/>
+        </p:spPr>
+        <p:txBody>
+          <a:bodyPr wrap="square" lIns="0" tIns="0" rIns="0" bIns="0" rtlCol="0" anchor="t"/>
+          <a:lstStyle/>
+          <a:p>
+            <a:pPr algn="l" indent="0" marL="0">
+              <a:lnSpc>
+                <a:spcPct val="110000"/>
+              </a:lnSpc>
+              <a:buNone/>
+            </a:pPr>
+            <a:r>
+              <a:rPr lang="en-US" sz="1400" dirty="0">
+                <a:solidFill>
+                  <a:srgbClr val="536177"/>
+                </a:solidFill>
+                <a:latin typeface="Calibri" pitchFamily="34" charset="0"/>
+                <a:ea typeface="Calibri" pitchFamily="34" charset="-122"/>
+                <a:cs typeface="Calibri" pitchFamily="34" charset="-120"/>
+              </a:rPr>
+              <a:t>Green Lion 2024-1: our engine re-runs the deal's own published Notes &amp; Cash waterfall. No report distribution figures fed in — Class A interest is computed (balance × coupon × days/360).</a:t>
+            </a:r>
+            <a:endParaRPr lang="en-US" sz="1400" dirty="0"/>
+          </a:p>
+        </p:txBody>
+      </p:sp>
+      <p:sp>
+        <p:nvSpPr>
+          <p:cNvPr id="9" name="Shape 7"/>
+          <p:cNvSpPr/>
+          <p:nvPr/>
+        </p:nvSpPr>
+        <p:spPr>
+          <a:xfrm>
+            <a:off x="640080" y="2423160"/>
+            <a:ext cx="2583866" cy="1783080"/>
+          </a:xfrm>
+          <a:prstGeom prst="roundRect">
+            <a:avLst>
+              <a:gd name="adj" fmla="val 2564"/>
+            </a:avLst>
+          </a:prstGeom>
+          <a:solidFill>
+            <a:srgbClr val="F4F7FB"/>
+          </a:solidFill>
+          <a:ln w="12700">
+            <a:solidFill>
+              <a:srgbClr val="DDE4EE"/>
+            </a:solidFill>
+            <a:prstDash val="solid"/>
+          </a:ln>
+          <a:effectLst>
+            <a:outerShdw sx="100000" sy="100000" kx="0" ky="0" algn="bl" rotWithShape="0" blurRad="88900" dist="38100" dir="5400000">
+              <a:srgbClr val="1B2A4A">
+                <a:alpha val="12000"/>
+              </a:srgbClr>
+            </a:outerShdw>
+          </a:effectLst>
+        </p:spPr>
+      </p:sp>
+      <p:sp>
+        <p:nvSpPr>
+          <p:cNvPr id="10" name="Text 8"/>
+          <p:cNvSpPr/>
+          <p:nvPr/>
+        </p:nvSpPr>
+        <p:spPr>
+          <a:xfrm>
+            <a:off x="640080" y="2606040"/>
+            <a:ext cx="2583866" cy="777240"/>
+          </a:xfrm>
+          <a:prstGeom prst="rect">
+            <a:avLst/>
+          </a:prstGeom>
+          <a:noFill/>
+          <a:ln/>
+        </p:spPr>
+        <p:txBody>
+          <a:bodyPr wrap="square" lIns="0" tIns="0" rIns="0" bIns="0" rtlCol="0" anchor="t"/>
+          <a:lstStyle/>
+          <a:p>
+            <a:pPr algn="ctr" indent="0" marL="0">
+              <a:lnSpc>
+                <a:spcPct val="100000"/>
+              </a:lnSpc>
+              <a:buNone/>
+            </a:pPr>
+            <a:r>
+              <a:rPr lang="en-US" sz="4200" b="1" dirty="0">
+                <a:solidFill>
+                  <a:srgbClr val="2B59D6"/>
+                </a:solidFill>
+                <a:latin typeface="Calibri" pitchFamily="34" charset="0"/>
+                <a:ea typeface="Calibri" pitchFamily="34" charset="-122"/>
+                <a:cs typeface="Calibri" pitchFamily="34" charset="-120"/>
+              </a:rPr>
+              <a:t>11/11</a:t>
+            </a:r>
+            <a:endParaRPr lang="en-US" sz="4200" dirty="0"/>
+          </a:p>
+        </p:txBody>
+      </p:sp>
+      <p:sp>
+        <p:nvSpPr>
+          <p:cNvPr id="11" name="Text 9"/>
+          <p:cNvSpPr/>
+          <p:nvPr/>
+        </p:nvSpPr>
+        <p:spPr>
+          <a:xfrm>
+            <a:off x="640080" y="3383280"/>
+            <a:ext cx="2583866" cy="320040"/>
+          </a:xfrm>
+          <a:prstGeom prst="rect">
+            <a:avLst/>
+          </a:prstGeom>
+          <a:noFill/>
+          <a:ln/>
+        </p:spPr>
+        <p:txBody>
+          <a:bodyPr wrap="square" lIns="0" tIns="0" rIns="0" bIns="0" rtlCol="0" anchor="t"/>
+          <a:lstStyle/>
+          <a:p>
+            <a:pPr algn="ctr" indent="0" marL="0">
+              <a:lnSpc>
+                <a:spcPct val="100000"/>
+              </a:lnSpc>
+              <a:buNone/>
+            </a:pPr>
+            <a:r>
+              <a:rPr lang="en-US" sz="1400" b="1" dirty="0">
+                <a:solidFill>
+                  <a:srgbClr val="1B2A4A"/>
+                </a:solidFill>
+                <a:latin typeface="Calibri" pitchFamily="34" charset="0"/>
+                <a:ea typeface="Calibri" pitchFamily="34" charset="-122"/>
+                <a:cs typeface="Calibri" pitchFamily="34" charset="-120"/>
+              </a:rPr>
+              <a:t>revenue PoP steps</a:t>
+            </a:r>
+            <a:endParaRPr lang="en-US" sz="1400" dirty="0"/>
+          </a:p>
+        </p:txBody>
+      </p:sp>
+      <p:sp>
+        <p:nvSpPr>
+          <p:cNvPr id="12" name="Text 10"/>
+          <p:cNvSpPr/>
+          <p:nvPr/>
+        </p:nvSpPr>
+        <p:spPr>
+          <a:xfrm>
+            <a:off x="804672" y="3703320"/>
+            <a:ext cx="2254682" cy="411480"/>
+          </a:xfrm>
+          <a:prstGeom prst="rect">
+            <a:avLst/>
+          </a:prstGeom>
+          <a:noFill/>
+          <a:ln/>
+        </p:spPr>
+        <p:txBody>
+          <a:bodyPr wrap="square" lIns="0" tIns="0" rIns="0" bIns="0" rtlCol="0" anchor="t"/>
+          <a:lstStyle/>
+          <a:p>
+            <a:pPr algn="ctr" indent="0" marL="0">
+              <a:lnSpc>
+                <a:spcPct val="100000"/>
+              </a:lnSpc>
+              <a:buNone/>
+            </a:pPr>
+            <a:r>
+              <a:rPr lang="en-US" sz="1000" dirty="0">
+                <a:solidFill>
+                  <a:srgbClr val="536177"/>
+                </a:solidFill>
+                <a:latin typeface="Calibri" pitchFamily="34" charset="0"/>
+                <a:ea typeface="Calibri" pitchFamily="34" charset="-122"/>
+                <a:cs typeface="Calibri" pitchFamily="34" charset="-120"/>
+              </a:rPr>
+              <a:t>reconciled to the cent</a:t>
+            </a:r>
+            <a:endParaRPr lang="en-US" sz="1000" dirty="0"/>
+          </a:p>
+        </p:txBody>
+      </p:sp>
+      <p:sp>
+        <p:nvSpPr>
+          <p:cNvPr id="13" name="Shape 11"/>
+          <p:cNvSpPr/>
+          <p:nvPr/>
+        </p:nvSpPr>
+        <p:spPr>
+          <a:xfrm>
+            <a:off x="3415970" y="2423160"/>
+            <a:ext cx="2583866" cy="1783080"/>
+          </a:xfrm>
+          <a:prstGeom prst="roundRect">
+            <a:avLst>
+              <a:gd name="adj" fmla="val 2564"/>
+            </a:avLst>
+          </a:prstGeom>
+          <a:solidFill>
+            <a:srgbClr val="F4F7FB"/>
+          </a:solidFill>
+          <a:ln w="12700">
+            <a:solidFill>
+              <a:srgbClr val="DDE4EE"/>
+            </a:solidFill>
+            <a:prstDash val="solid"/>
+          </a:ln>
+          <a:effectLst>
+            <a:outerShdw sx="100000" sy="100000" kx="0" ky="0" algn="bl" rotWithShape="0" blurRad="88900" dist="38100" dir="5400000">
+              <a:srgbClr val="1B2A4A">
+                <a:alpha val="12000"/>
+              </a:srgbClr>
+            </a:outerShdw>
+          </a:effectLst>
+        </p:spPr>
+      </p:sp>
+      <p:sp>
+        <p:nvSpPr>
+          <p:cNvPr id="14" name="Text 12"/>
+          <p:cNvSpPr/>
+          <p:nvPr/>
+        </p:nvSpPr>
+        <p:spPr>
+          <a:xfrm>
+            <a:off x="3415970" y="2606040"/>
+            <a:ext cx="2583866" cy="777240"/>
+          </a:xfrm>
+          <a:prstGeom prst="rect">
+            <a:avLst/>
+          </a:prstGeom>
+          <a:noFill/>
+          <a:ln/>
+        </p:spPr>
+        <p:txBody>
+          <a:bodyPr wrap="square" lIns="0" tIns="0" rIns="0" bIns="0" rtlCol="0" anchor="t"/>
+          <a:lstStyle/>
+          <a:p>
+            <a:pPr algn="ctr" indent="0" marL="0">
+              <a:lnSpc>
+                <a:spcPct val="100000"/>
+              </a:lnSpc>
+              <a:buNone/>
+            </a:pPr>
+            <a:r>
+              <a:rPr lang="en-US" sz="4200" b="1" dirty="0">
+                <a:solidFill>
+                  <a:srgbClr val="2B59D6"/>
+                </a:solidFill>
+                <a:latin typeface="Calibri" pitchFamily="34" charset="0"/>
+                <a:ea typeface="Calibri" pitchFamily="34" charset="-122"/>
+                <a:cs typeface="Calibri" pitchFamily="34" charset="-120"/>
+              </a:rPr>
+              <a:t>4/4</a:t>
+            </a:r>
+            <a:endParaRPr lang="en-US" sz="4200" dirty="0"/>
+          </a:p>
+        </p:txBody>
+      </p:sp>
+      <p:sp>
+        <p:nvSpPr>
+          <p:cNvPr id="15" name="Text 13"/>
+          <p:cNvSpPr/>
+          <p:nvPr/>
+        </p:nvSpPr>
+        <p:spPr>
+          <a:xfrm>
+            <a:off x="3415970" y="3383280"/>
+            <a:ext cx="2583866" cy="320040"/>
+          </a:xfrm>
+          <a:prstGeom prst="rect">
+            <a:avLst/>
+          </a:prstGeom>
+          <a:noFill/>
+          <a:ln/>
+        </p:spPr>
+        <p:txBody>
+          <a:bodyPr wrap="square" lIns="0" tIns="0" rIns="0" bIns="0" rtlCol="0" anchor="t"/>
+          <a:lstStyle/>
+          <a:p>
+            <a:pPr algn="ctr" indent="0" marL="0">
+              <a:lnSpc>
+                <a:spcPct val="100000"/>
+              </a:lnSpc>
+              <a:buNone/>
+            </a:pPr>
+            <a:r>
+              <a:rPr lang="en-US" sz="1400" b="1" dirty="0">
+                <a:solidFill>
+                  <a:srgbClr val="1B2A4A"/>
+                </a:solidFill>
+                <a:latin typeface="Calibri" pitchFamily="34" charset="0"/>
+                <a:ea typeface="Calibri" pitchFamily="34" charset="-122"/>
+                <a:cs typeface="Calibri" pitchFamily="34" charset="-120"/>
+              </a:rPr>
+              <a:t>redemption steps</a:t>
+            </a:r>
+            <a:endParaRPr lang="en-US" sz="1400" dirty="0"/>
+          </a:p>
+        </p:txBody>
+      </p:sp>
+      <p:sp>
+        <p:nvSpPr>
+          <p:cNvPr id="16" name="Text 14"/>
+          <p:cNvSpPr/>
+          <p:nvPr/>
+        </p:nvSpPr>
+        <p:spPr>
+          <a:xfrm>
+            <a:off x="3580562" y="3703320"/>
+            <a:ext cx="2254682" cy="411480"/>
+          </a:xfrm>
+          <a:prstGeom prst="rect">
+            <a:avLst/>
+          </a:prstGeom>
+          <a:noFill/>
+          <a:ln/>
+        </p:spPr>
+        <p:txBody>
+          <a:bodyPr wrap="square" lIns="0" tIns="0" rIns="0" bIns="0" rtlCol="0" anchor="t"/>
+          <a:lstStyle/>
+          <a:p>
+            <a:pPr algn="ctr" indent="0" marL="0">
+              <a:lnSpc>
+                <a:spcPct val="100000"/>
+              </a:lnSpc>
+              <a:buNone/>
+            </a:pPr>
+            <a:r>
+              <a:rPr lang="en-US" sz="1000" dirty="0">
+                <a:solidFill>
+                  <a:srgbClr val="536177"/>
+                </a:solidFill>
+                <a:latin typeface="Calibri" pitchFamily="34" charset="0"/>
+                <a:ea typeface="Calibri" pitchFamily="34" charset="-122"/>
+                <a:cs typeface="Calibri" pitchFamily="34" charset="-120"/>
+              </a:rPr>
+              <a:t>to the cent</a:t>
+            </a:r>
+            <a:endParaRPr lang="en-US" sz="1000" dirty="0"/>
+          </a:p>
+        </p:txBody>
+      </p:sp>
+      <p:sp>
+        <p:nvSpPr>
+          <p:cNvPr id="17" name="Shape 15"/>
+          <p:cNvSpPr/>
+          <p:nvPr/>
+        </p:nvSpPr>
+        <p:spPr>
+          <a:xfrm>
+            <a:off x="6191860" y="2423160"/>
+            <a:ext cx="2583866" cy="1783080"/>
+          </a:xfrm>
+          <a:prstGeom prst="roundRect">
+            <a:avLst>
+              <a:gd name="adj" fmla="val 2564"/>
+            </a:avLst>
+          </a:prstGeom>
+          <a:solidFill>
+            <a:srgbClr val="F4F7FB"/>
+          </a:solidFill>
+          <a:ln w="12700">
+            <a:solidFill>
+              <a:srgbClr val="DDE4EE"/>
+            </a:solidFill>
+            <a:prstDash val="solid"/>
+          </a:ln>
+          <a:effectLst>
+            <a:outerShdw sx="100000" sy="100000" kx="0" ky="0" algn="bl" rotWithShape="0" blurRad="88900" dist="38100" dir="5400000">
+              <a:srgbClr val="1B2A4A">
+                <a:alpha val="12000"/>
+              </a:srgbClr>
+            </a:outerShdw>
+          </a:effectLst>
+        </p:spPr>
+      </p:sp>
+      <p:sp>
+        <p:nvSpPr>
+          <p:cNvPr id="18" name="Text 16"/>
+          <p:cNvSpPr/>
+          <p:nvPr/>
+        </p:nvSpPr>
+        <p:spPr>
+          <a:xfrm>
+            <a:off x="6191860" y="2606040"/>
+            <a:ext cx="2583866" cy="777240"/>
+          </a:xfrm>
+          <a:prstGeom prst="rect">
+            <a:avLst/>
+          </a:prstGeom>
+          <a:noFill/>
+          <a:ln/>
+        </p:spPr>
+        <p:txBody>
+          <a:bodyPr wrap="square" lIns="0" tIns="0" rIns="0" bIns="0" rtlCol="0" anchor="t"/>
+          <a:lstStyle/>
+          <a:p>
+            <a:pPr algn="ctr" indent="0" marL="0">
+              <a:lnSpc>
+                <a:spcPct val="100000"/>
+              </a:lnSpc>
+              <a:buNone/>
+            </a:pPr>
+            <a:r>
+              <a:rPr lang="en-US" sz="4200" b="1" dirty="0">
+                <a:solidFill>
+                  <a:srgbClr val="2B59D6"/>
+                </a:solidFill>
+                <a:latin typeface="Calibri" pitchFamily="34" charset="0"/>
+                <a:ea typeface="Calibri" pitchFamily="34" charset="-122"/>
+                <a:cs typeface="Calibri" pitchFamily="34" charset="-120"/>
+              </a:rPr>
+              <a:t>€0.00</a:t>
+            </a:r>
+            <a:endParaRPr lang="en-US" sz="4200" dirty="0"/>
+          </a:p>
+        </p:txBody>
+      </p:sp>
+      <p:sp>
+        <p:nvSpPr>
+          <p:cNvPr id="19" name="Text 17"/>
+          <p:cNvSpPr/>
+          <p:nvPr/>
+        </p:nvSpPr>
+        <p:spPr>
+          <a:xfrm>
+            <a:off x="6191860" y="3383280"/>
+            <a:ext cx="2583866" cy="320040"/>
+          </a:xfrm>
+          <a:prstGeom prst="rect">
+            <a:avLst/>
+          </a:prstGeom>
+          <a:noFill/>
+          <a:ln/>
+        </p:spPr>
+        <p:txBody>
+          <a:bodyPr wrap="square" lIns="0" tIns="0" rIns="0" bIns="0" rtlCol="0" anchor="t"/>
+          <a:lstStyle/>
+          <a:p>
+            <a:pPr algn="ctr" indent="0" marL="0">
+              <a:lnSpc>
+                <a:spcPct val="100000"/>
+              </a:lnSpc>
+              <a:buNone/>
+            </a:pPr>
+            <a:r>
+              <a:rPr lang="en-US" sz="1400" b="1" dirty="0">
+                <a:solidFill>
+                  <a:srgbClr val="1B2A4A"/>
+                </a:solidFill>
+                <a:latin typeface="Calibri" pitchFamily="34" charset="0"/>
+                <a:ea typeface="Calibri" pitchFamily="34" charset="-122"/>
+                <a:cs typeface="Calibri" pitchFamily="34" charset="-120"/>
+              </a:rPr>
+              <a:t>reconciliation gap</a:t>
+            </a:r>
+            <a:endParaRPr lang="en-US" sz="1400" dirty="0"/>
+          </a:p>
+        </p:txBody>
+      </p:sp>
+      <p:sp>
+        <p:nvSpPr>
+          <p:cNvPr id="20" name="Text 18"/>
+          <p:cNvSpPr/>
+          <p:nvPr/>
+        </p:nvSpPr>
+        <p:spPr>
+          <a:xfrm>
+            <a:off x="6356452" y="3703320"/>
+            <a:ext cx="2254682" cy="411480"/>
+          </a:xfrm>
+          <a:prstGeom prst="rect">
+            <a:avLst/>
+          </a:prstGeom>
+          <a:noFill/>
+          <a:ln/>
+        </p:spPr>
+        <p:txBody>
+          <a:bodyPr wrap="square" lIns="0" tIns="0" rIns="0" bIns="0" rtlCol="0" anchor="t"/>
+          <a:lstStyle/>
+          <a:p>
+            <a:pPr algn="ctr" indent="0" marL="0">
+              <a:lnSpc>
+                <a:spcPct val="100000"/>
+              </a:lnSpc>
+              <a:buNone/>
+            </a:pPr>
+            <a:r>
+              <a:rPr lang="en-US" sz="1000" dirty="0">
+                <a:solidFill>
+                  <a:srgbClr val="536177"/>
+                </a:solidFill>
+                <a:latin typeface="Calibri" pitchFamily="34" charset="0"/>
+                <a:ea typeface="Calibri" pitchFamily="34" charset="-122"/>
+                <a:cs typeface="Calibri" pitchFamily="34" charset="-120"/>
+              </a:rPr>
+              <a:t>the report's own €0.69 rounding modelled, not fudged</a:t>
+            </a:r>
+            <a:endParaRPr lang="en-US" sz="1000" dirty="0"/>
+          </a:p>
+        </p:txBody>
+      </p:sp>
+      <p:sp>
+        <p:nvSpPr>
+          <p:cNvPr id="21" name="Shape 19"/>
+          <p:cNvSpPr/>
+          <p:nvPr/>
+        </p:nvSpPr>
+        <p:spPr>
+          <a:xfrm>
+            <a:off x="8967749" y="2423160"/>
+            <a:ext cx="2583866" cy="1783080"/>
+          </a:xfrm>
+          <a:prstGeom prst="roundRect">
+            <a:avLst>
+              <a:gd name="adj" fmla="val 2564"/>
+            </a:avLst>
+          </a:prstGeom>
+          <a:solidFill>
+            <a:srgbClr val="F4F7FB"/>
+          </a:solidFill>
+          <a:ln w="12700">
+            <a:solidFill>
+              <a:srgbClr val="DDE4EE"/>
+            </a:solidFill>
+            <a:prstDash val="solid"/>
+          </a:ln>
+          <a:effectLst>
+            <a:outerShdw sx="100000" sy="100000" kx="0" ky="0" algn="bl" rotWithShape="0" blurRad="88900" dist="38100" dir="5400000">
+              <a:srgbClr val="1B2A4A">
+                <a:alpha val="12000"/>
+              </a:srgbClr>
+            </a:outerShdw>
+          </a:effectLst>
+        </p:spPr>
+      </p:sp>
+      <p:sp>
+        <p:nvSpPr>
+          <p:cNvPr id="22" name="Text 20"/>
+          <p:cNvSpPr/>
+          <p:nvPr/>
+        </p:nvSpPr>
+        <p:spPr>
+          <a:xfrm>
+            <a:off x="8967749" y="2606040"/>
+            <a:ext cx="2583866" cy="777240"/>
+          </a:xfrm>
+          <a:prstGeom prst="rect">
+            <a:avLst/>
+          </a:prstGeom>
+          <a:noFill/>
+          <a:ln/>
+        </p:spPr>
+        <p:txBody>
+          <a:bodyPr wrap="square" lIns="0" tIns="0" rIns="0" bIns="0" rtlCol="0" anchor="t"/>
+          <a:lstStyle/>
+          <a:p>
+            <a:pPr algn="ctr" indent="0" marL="0">
+              <a:lnSpc>
+                <a:spcPct val="100000"/>
+              </a:lnSpc>
+              <a:buNone/>
+            </a:pPr>
+            <a:r>
+              <a:rPr lang="en-US" sz="4200" b="1" dirty="0">
+                <a:solidFill>
+                  <a:srgbClr val="2B59D6"/>
+                </a:solidFill>
+                <a:latin typeface="Calibri" pitchFamily="34" charset="0"/>
+                <a:ea typeface="Calibri" pitchFamily="34" charset="-122"/>
+                <a:cs typeface="Calibri" pitchFamily="34" charset="-120"/>
+              </a:rPr>
+              <a:t>1</a:t>
+            </a:r>
+            <a:endParaRPr lang="en-US" sz="4200" dirty="0"/>
+          </a:p>
+        </p:txBody>
+      </p:sp>
+      <p:sp>
+        <p:nvSpPr>
+          <p:cNvPr id="23" name="Text 21"/>
+          <p:cNvSpPr/>
+          <p:nvPr/>
+        </p:nvSpPr>
+        <p:spPr>
+          <a:xfrm>
+            <a:off x="8967749" y="3383280"/>
+            <a:ext cx="2583866" cy="320040"/>
+          </a:xfrm>
+          <a:prstGeom prst="rect">
+            <a:avLst/>
+          </a:prstGeom>
+          <a:noFill/>
+          <a:ln/>
+        </p:spPr>
+        <p:txBody>
+          <a:bodyPr wrap="square" lIns="0" tIns="0" rIns="0" bIns="0" rtlCol="0" anchor="t"/>
+          <a:lstStyle/>
+          <a:p>
+            <a:pPr algn="ctr" indent="0" marL="0">
+              <a:lnSpc>
+                <a:spcPct val="100000"/>
+              </a:lnSpc>
+              <a:buNone/>
+            </a:pPr>
+            <a:r>
+              <a:rPr lang="en-US" sz="1400" b="1" dirty="0">
+                <a:solidFill>
+                  <a:srgbClr val="1B2A4A"/>
+                </a:solidFill>
+                <a:latin typeface="Calibri" pitchFamily="34" charset="0"/>
+                <a:ea typeface="Calibri" pitchFamily="34" charset="-122"/>
+                <a:cs typeface="Calibri" pitchFamily="34" charset="-120"/>
+              </a:rPr>
+              <a:t>real ING deal</a:t>
+            </a:r>
+            <a:endParaRPr lang="en-US" sz="1400" dirty="0"/>
+          </a:p>
+        </p:txBody>
+      </p:sp>
+      <p:sp>
+        <p:nvSpPr>
+          <p:cNvPr id="24" name="Text 22"/>
+          <p:cNvSpPr/>
+          <p:nvPr/>
+        </p:nvSpPr>
+        <p:spPr>
+          <a:xfrm>
+            <a:off x="9132341" y="3703320"/>
+            <a:ext cx="2254682" cy="411480"/>
+          </a:xfrm>
+          <a:prstGeom prst="rect">
+            <a:avLst/>
+          </a:prstGeom>
+          <a:noFill/>
+          <a:ln/>
+        </p:spPr>
+        <p:txBody>
+          <a:bodyPr wrap="square" lIns="0" tIns="0" rIns="0" bIns="0" rtlCol="0" anchor="t"/>
+          <a:lstStyle/>
+          <a:p>
+            <a:pPr algn="ctr" indent="0" marL="0">
+              <a:lnSpc>
+                <a:spcPct val="100000"/>
+              </a:lnSpc>
+              <a:buNone/>
+            </a:pPr>
+            <a:r>
+              <a:rPr lang="en-US" sz="1000" dirty="0">
+                <a:solidFill>
+                  <a:srgbClr val="536177"/>
+                </a:solidFill>
+                <a:latin typeface="Calibri" pitchFamily="34" charset="0"/>
+                <a:ea typeface="Calibri" pitchFamily="34" charset="-122"/>
+                <a:cs typeface="Calibri" pitchFamily="34" charset="-120"/>
+              </a:rPr>
+              <a:t>its own published quarterly report</a:t>
+            </a:r>
+            <a:endParaRPr lang="en-US" sz="1000" dirty="0"/>
+          </a:p>
+        </p:txBody>
+      </p:sp>
+    </p:spTree>
+  </p:cSld>
+  <p:clrMapOvr>
+    <a:masterClrMapping/>
+  </p:clrMapOvr>
+</p:sld>
+</file>
+
+<file path=ppt/slides/slide5.xml><?xml version="1.0" encoding="utf-8"?>
+<p:sld xmlns:a="http://schemas.openxmlformats.org/drawingml/2006/main" xmlns:r="http://schemas.openxmlformats.org/officeDocument/2006/relationships" xmlns:p="http://schemas.openxmlformats.org/presentationml/2006/main">
+  <p:cSld name="Slide 5">
+    <p:bg>
+      <p:bgPr>
+        <a:solidFill>
+          <a:srgbClr val="FFFFFF"/>
+        </a:solidFill>
+      </p:bgPr>
+    </p:bg>
+    <p:spTree>
+      <p:nvGrpSpPr>
+        <p:cNvPr id="1" name=""/>
+        <p:cNvGrpSpPr/>
+        <p:nvPr/>
+      </p:nvGrpSpPr>
+      <p:grpSpPr>
+        <a:xfrm>
+          <a:off x="0" y="0"/>
+          <a:ext cx="0" cy="0"/>
+          <a:chOff x="0" y="0"/>
+          <a:chExt cx="0" cy="0"/>
+        </a:xfrm>
+      </p:grpSpPr>
+      <p:sp>
+        <p:nvSpPr>
+          <p:cNvPr id="2" name="Shape 0"/>
+          <p:cNvSpPr/>
+          <p:nvPr/>
+        </p:nvSpPr>
+        <p:spPr>
+          <a:xfrm>
+            <a:off x="0" y="0"/>
+            <a:ext cx="164592" cy="6858000"/>
+          </a:xfrm>
+          <a:prstGeom prst="rect">
+            <a:avLst/>
+          </a:prstGeom>
+          <a:solidFill>
+            <a:srgbClr val="2B59D6"/>
+          </a:solidFill>
+          <a:ln/>
+        </p:spPr>
+      </p:sp>
+      <p:sp>
+        <p:nvSpPr>
+          <p:cNvPr id="3" name="Text 1"/>
+          <p:cNvSpPr/>
+          <p:nvPr/>
+        </p:nvSpPr>
+        <p:spPr>
+          <a:xfrm>
+            <a:off x="640080" y="384048"/>
+            <a:ext cx="10789920" cy="274320"/>
+          </a:xfrm>
+          <a:prstGeom prst="rect">
+            <a:avLst/>
+          </a:prstGeom>
+          <a:noFill/>
+          <a:ln/>
+        </p:spPr>
+        <p:txBody>
+          <a:bodyPr wrap="square" lIns="0" tIns="0" rIns="0" bIns="0" rtlCol="0" anchor="t"/>
+          <a:lstStyle/>
+          <a:p>
+            <a:pPr algn="l" indent="0" marL="0">
+              <a:lnSpc>
+                <a:spcPct val="100000"/>
+              </a:lnSpc>
+              <a:buNone/>
+            </a:pPr>
+            <a:r>
+              <a:rPr lang="en-US" sz="1200" b="1" dirty="0">
+                <a:solidFill>
+                  <a:srgbClr val="129E8F"/>
+                </a:solidFill>
+                <a:latin typeface="Calibri" pitchFamily="34" charset="0"/>
+                <a:ea typeface="Calibri" pitchFamily="34" charset="-122"/>
+                <a:cs typeface="Calibri" pitchFamily="34" charset="-120"/>
+              </a:rPr>
+              <a:t>BROADLY APPLICABLE — NOT HARDCODED</a:t>
+            </a:r>
+            <a:endParaRPr lang="en-US" sz="1200" dirty="0"/>
+          </a:p>
+        </p:txBody>
+      </p:sp>
+      <p:sp>
+        <p:nvSpPr>
+          <p:cNvPr id="4" name="Text 2"/>
+          <p:cNvSpPr/>
+          <p:nvPr/>
+        </p:nvSpPr>
+        <p:spPr>
+          <a:xfrm>
+            <a:off x="640080" y="658368"/>
+            <a:ext cx="10881360" cy="822960"/>
+          </a:xfrm>
+          <a:prstGeom prst="rect">
+            <a:avLst/>
+          </a:prstGeom>
+          <a:noFill/>
+          <a:ln/>
+        </p:spPr>
+        <p:txBody>
+          <a:bodyPr wrap="square" lIns="0" tIns="0" rIns="0" bIns="0" rtlCol="0" anchor="t"/>
+          <a:lstStyle/>
+          <a:p>
+            <a:pPr algn="l" indent="0" marL="0">
+              <a:lnSpc>
+                <a:spcPct val="100000"/>
+              </a:lnSpc>
+              <a:buNone/>
+            </a:pPr>
+            <a:r>
+              <a:rPr lang="en-US" sz="2800" b="1" dirty="0">
+                <a:solidFill>
+                  <a:srgbClr val="1B2A4A"/>
+                </a:solidFill>
+                <a:latin typeface="Calibri" pitchFamily="34" charset="0"/>
+                <a:ea typeface="Calibri" pitchFamily="34" charset="-122"/>
+                <a:cs typeface="Calibri" pitchFamily="34" charset="-120"/>
+              </a:rPr>
+              <a:t>The same primitives across three jurisdictions</a:t>
+            </a:r>
+            <a:endParaRPr lang="en-US" sz="2800" dirty="0"/>
+          </a:p>
+        </p:txBody>
+      </p:sp>
+      <p:sp>
+        <p:nvSpPr>
+          <p:cNvPr id="5" name="Shape 3"/>
+          <p:cNvSpPr/>
+          <p:nvPr/>
+        </p:nvSpPr>
+        <p:spPr>
+          <a:xfrm>
+            <a:off x="658368" y="1335024"/>
+            <a:ext cx="548640" cy="36576"/>
+          </a:xfrm>
+          <a:prstGeom prst="rect">
+            <a:avLst/>
+          </a:prstGeom>
+          <a:solidFill>
+            <a:srgbClr val="129E8F"/>
+          </a:solidFill>
+          <a:ln/>
+        </p:spPr>
+      </p:sp>
+      <p:sp>
+        <p:nvSpPr>
+          <p:cNvPr id="6" name="Text 4"/>
+          <p:cNvSpPr/>
+          <p:nvPr/>
+        </p:nvSpPr>
+        <p:spPr>
+          <a:xfrm>
+            <a:off x="640080" y="6437376"/>
+            <a:ext cx="7315200" cy="274320"/>
+          </a:xfrm>
+          <a:prstGeom prst="rect">
+            <a:avLst/>
+          </a:prstGeom>
+          <a:noFill/>
+          <a:ln/>
+        </p:spPr>
+        <p:txBody>
+          <a:bodyPr wrap="square" lIns="0" tIns="0" rIns="0" bIns="0" rtlCol="0" anchor="t"/>
+          <a:lstStyle/>
+          <a:p>
+            <a:pPr algn="l" indent="0" marL="0">
+              <a:lnSpc>
+                <a:spcPct val="100000"/>
+              </a:lnSpc>
+              <a:buNone/>
+            </a:pPr>
+            <a:r>
+              <a:rPr lang="en-US" sz="900" b="1" dirty="0">
+                <a:solidFill>
+                  <a:srgbClr val="536177"/>
+                </a:solidFill>
+                <a:latin typeface="Calibri" pitchFamily="34" charset="0"/>
+                <a:ea typeface="Calibri" pitchFamily="34" charset="-122"/>
+                <a:cs typeface="Calibri" pitchFamily="34" charset="-120"/>
+              </a:rPr>
+              <a:t>LoanWhiz</a:t>
+            </a:r>
+            <a:pPr algn="l" indent="0" marL="0">
+              <a:lnSpc>
+                <a:spcPct val="100000"/>
+              </a:lnSpc>
+              <a:buNone/>
+            </a:pPr>
+            <a:r>
+              <a:rPr lang="en-US" sz="900" dirty="0">
+                <a:solidFill>
+                  <a:srgbClr val="6B7A90"/>
+                </a:solidFill>
+                <a:latin typeface="Calibri" pitchFamily="34" charset="0"/>
+                <a:ea typeface="Calibri" pitchFamily="34" charset="-122"/>
+                <a:cs typeface="Calibri" pitchFamily="34" charset="-120"/>
+              </a:rPr>
+              <a:t>  ·  Structured Finance Agent Framework</a:t>
+            </a:r>
+            <a:endParaRPr lang="en-US" sz="900" dirty="0"/>
+          </a:p>
+        </p:txBody>
+      </p:sp>
+      <p:sp>
+        <p:nvSpPr>
+          <p:cNvPr id="7" name="Text 5"/>
+          <p:cNvSpPr/>
+          <p:nvPr/>
+        </p:nvSpPr>
+        <p:spPr>
+          <a:xfrm>
+            <a:off x="10058400" y="6437376"/>
+            <a:ext cx="502920" cy="274320"/>
+          </a:xfrm>
+          <a:prstGeom prst="rect">
+            <a:avLst/>
+          </a:prstGeom>
+          <a:noFill/>
+          <a:ln/>
+        </p:spPr>
+        <p:txBody>
+          <a:bodyPr wrap="square" lIns="0" tIns="0" rIns="0" bIns="0" rtlCol="0" anchor="t"/>
+          <a:lstStyle/>
+          <a:p>
+            <a:pPr algn="r" indent="0" marL="0">
+              <a:lnSpc>
+                <a:spcPct val="100000"/>
+              </a:lnSpc>
+              <a:buNone/>
+            </a:pPr>
+            <a:r>
+              <a:rPr lang="en-US" sz="900" dirty="0">
+                <a:solidFill>
+                  <a:srgbClr val="6B7A90"/>
+                </a:solidFill>
+                <a:latin typeface="Calibri" pitchFamily="34" charset="0"/>
+                <a:ea typeface="Calibri" pitchFamily="34" charset="-122"/>
+                <a:cs typeface="Calibri" pitchFamily="34" charset="-120"/>
+              </a:rPr>
+              <a:t>05</a:t>
+            </a:r>
+            <a:endParaRPr lang="en-US" sz="900" dirty="0"/>
+          </a:p>
+        </p:txBody>
+      </p:sp>
       <p:graphicFrame>
         <p:nvGraphicFramePr>
-          <p:cNvPr id="5" name="Table 0"/>
+          <p:cNvPr id="6" name="Table 0"/>
           <p:cNvGraphicFramePr>
             <a:graphicFrameLocks noGrp="1"/>
           </p:cNvGraphicFramePr>
@@ -5956,9 +7128,9 @@
 </p:sld>
 </file>
 
-<file path=ppt/slides/slide5.xml><?xml version="1.0" encoding="utf-8"?>
+<file path=ppt/slides/slide6.xml><?xml version="1.0" encoding="utf-8"?>
 <p:sld xmlns:a="http://schemas.openxmlformats.org/drawingml/2006/main" xmlns:r="http://schemas.openxmlformats.org/officeDocument/2006/relationships" xmlns:p="http://schemas.openxmlformats.org/presentationml/2006/main">
-  <p:cSld name="Slide 5">
+  <p:cSld name="Slide 6">
     <p:bg>
       <p:bgPr>
         <a:solidFill>
@@ -6123,686 +7295,6 @@
               <a:t>GET /capability-matrix runs every primitive across every deal and renders it in the /showcase view: validated / ran / not-applicable, each cell carrying its real reason. Today: 1 validated, 9 ran, 15 not-applicable. N/A is shown as honest scope — never hidden, never coloured green.</a:t>
             </a:r>
             <a:endParaRPr lang="en-US" sz="1600" dirty="0"/>
-          </a:p>
-        </p:txBody>
-      </p:sp>
-    </p:spTree>
-  </p:cSld>
-  <p:clrMapOvr>
-    <a:masterClrMapping/>
-  </p:clrMapOvr>
-</p:sld>
-</file>
-
-<file path=ppt/slides/slide6.xml><?xml version="1.0" encoding="utf-8"?>
-<p:sld xmlns:a="http://schemas.openxmlformats.org/drawingml/2006/main" xmlns:r="http://schemas.openxmlformats.org/officeDocument/2006/relationships" xmlns:p="http://schemas.openxmlformats.org/presentationml/2006/main">
-  <p:cSld name="Slide 6">
-    <p:bg>
-      <p:bgPr>
-        <a:solidFill>
-          <a:srgbClr val="FFFFFF"/>
-        </a:solidFill>
-      </p:bgPr>
-    </p:bg>
-    <p:spTree>
-      <p:nvGrpSpPr>
-        <p:cNvPr id="1" name=""/>
-        <p:cNvGrpSpPr/>
-        <p:nvPr/>
-      </p:nvGrpSpPr>
-      <p:grpSpPr>
-        <a:xfrm>
-          <a:off x="0" y="0"/>
-          <a:ext cx="0" cy="0"/>
-          <a:chOff x="0" y="0"/>
-          <a:chExt cx="0" cy="0"/>
-        </a:xfrm>
-      </p:grpSpPr>
-      <p:sp>
-        <p:nvSpPr>
-          <p:cNvPr id="2" name="Shape 0"/>
-          <p:cNvSpPr/>
-          <p:nvPr/>
-        </p:nvSpPr>
-        <p:spPr>
-          <a:xfrm>
-            <a:off x="0" y="0"/>
-            <a:ext cx="164592" cy="6858000"/>
-          </a:xfrm>
-          <a:prstGeom prst="rect">
-            <a:avLst/>
-          </a:prstGeom>
-          <a:solidFill>
-            <a:srgbClr val="2B59D6"/>
-          </a:solidFill>
-          <a:ln/>
-        </p:spPr>
-      </p:sp>
-      <p:sp>
-        <p:nvSpPr>
-          <p:cNvPr id="3" name="Text 1"/>
-          <p:cNvSpPr/>
-          <p:nvPr/>
-        </p:nvSpPr>
-        <p:spPr>
-          <a:xfrm>
-            <a:off x="640080" y="384048"/>
-            <a:ext cx="10789920" cy="274320"/>
-          </a:xfrm>
-          <a:prstGeom prst="rect">
-            <a:avLst/>
-          </a:prstGeom>
-          <a:noFill/>
-          <a:ln/>
-        </p:spPr>
-        <p:txBody>
-          <a:bodyPr wrap="square" lIns="0" tIns="0" rIns="0" bIns="0" rtlCol="0" anchor="t"/>
-          <a:lstStyle/>
-          <a:p>
-            <a:pPr algn="l" indent="0" marL="0">
-              <a:lnSpc>
-                <a:spcPct val="100000"/>
-              </a:lnSpc>
-              <a:buNone/>
-            </a:pPr>
-            <a:r>
-              <a:rPr lang="en-US" sz="1200" b="1" dirty="0">
-                <a:solidFill>
-                  <a:srgbClr val="129E8F"/>
-                </a:solidFill>
-                <a:latin typeface="Calibri" pitchFamily="34" charset="0"/>
-                <a:ea typeface="Calibri" pitchFamily="34" charset="-122"/>
-                <a:cs typeface="Calibri" pitchFamily="34" charset="-120"/>
-              </a:rPr>
-              <a:t>PACKAGED FOR REUSE</a:t>
-            </a:r>
-            <a:endParaRPr lang="en-US" sz="1200" dirty="0"/>
-          </a:p>
-        </p:txBody>
-      </p:sp>
-      <p:sp>
-        <p:nvSpPr>
-          <p:cNvPr id="4" name="Text 2"/>
-          <p:cNvSpPr/>
-          <p:nvPr/>
-        </p:nvSpPr>
-        <p:spPr>
-          <a:xfrm>
-            <a:off x="640080" y="658368"/>
-            <a:ext cx="10881360" cy="822960"/>
-          </a:xfrm>
-          <a:prstGeom prst="rect">
-            <a:avLst/>
-          </a:prstGeom>
-          <a:noFill/>
-          <a:ln/>
-        </p:spPr>
-        <p:txBody>
-          <a:bodyPr wrap="square" lIns="0" tIns="0" rIns="0" bIns="0" rtlCol="0" anchor="t"/>
-          <a:lstStyle/>
-          <a:p>
-            <a:pPr algn="l" indent="0" marL="0">
-              <a:lnSpc>
-                <a:spcPct val="100000"/>
-              </a:lnSpc>
-              <a:buNone/>
-            </a:pPr>
-            <a:r>
-              <a:rPr lang="en-US" sz="2800" b="1" dirty="0">
-                <a:solidFill>
-                  <a:srgbClr val="1B2A4A"/>
-                </a:solidFill>
-                <a:latin typeface="Calibri" pitchFamily="34" charset="0"/>
-                <a:ea typeface="Calibri" pitchFamily="34" charset="-122"/>
-                <a:cs typeface="Calibri" pitchFamily="34" charset="-120"/>
-              </a:rPr>
-              <a:t>Reusable infrastructure, not a one-off</a:t>
-            </a:r>
-            <a:endParaRPr lang="en-US" sz="2800" dirty="0"/>
-          </a:p>
-        </p:txBody>
-      </p:sp>
-      <p:sp>
-        <p:nvSpPr>
-          <p:cNvPr id="5" name="Shape 3"/>
-          <p:cNvSpPr/>
-          <p:nvPr/>
-        </p:nvSpPr>
-        <p:spPr>
-          <a:xfrm>
-            <a:off x="658368" y="1335024"/>
-            <a:ext cx="548640" cy="36576"/>
-          </a:xfrm>
-          <a:prstGeom prst="rect">
-            <a:avLst/>
-          </a:prstGeom>
-          <a:solidFill>
-            <a:srgbClr val="129E8F"/>
-          </a:solidFill>
-          <a:ln/>
-        </p:spPr>
-      </p:sp>
-      <p:sp>
-        <p:nvSpPr>
-          <p:cNvPr id="6" name="Text 4"/>
-          <p:cNvSpPr/>
-          <p:nvPr/>
-        </p:nvSpPr>
-        <p:spPr>
-          <a:xfrm>
-            <a:off x="640080" y="6437376"/>
-            <a:ext cx="7315200" cy="274320"/>
-          </a:xfrm>
-          <a:prstGeom prst="rect">
-            <a:avLst/>
-          </a:prstGeom>
-          <a:noFill/>
-          <a:ln/>
-        </p:spPr>
-        <p:txBody>
-          <a:bodyPr wrap="square" lIns="0" tIns="0" rIns="0" bIns="0" rtlCol="0" anchor="t"/>
-          <a:lstStyle/>
-          <a:p>
-            <a:pPr algn="l" indent="0" marL="0">
-              <a:lnSpc>
-                <a:spcPct val="100000"/>
-              </a:lnSpc>
-              <a:buNone/>
-            </a:pPr>
-            <a:r>
-              <a:rPr lang="en-US" sz="900" b="1" dirty="0">
-                <a:solidFill>
-                  <a:srgbClr val="536177"/>
-                </a:solidFill>
-                <a:latin typeface="Calibri" pitchFamily="34" charset="0"/>
-                <a:ea typeface="Calibri" pitchFamily="34" charset="-122"/>
-                <a:cs typeface="Calibri" pitchFamily="34" charset="-120"/>
-              </a:rPr>
-              <a:t>LoanWhiz</a:t>
-            </a:r>
-            <a:pPr algn="l" indent="0" marL="0">
-              <a:lnSpc>
-                <a:spcPct val="100000"/>
-              </a:lnSpc>
-              <a:buNone/>
-            </a:pPr>
-            <a:r>
-              <a:rPr lang="en-US" sz="900" dirty="0">
-                <a:solidFill>
-                  <a:srgbClr val="6B7A90"/>
-                </a:solidFill>
-                <a:latin typeface="Calibri" pitchFamily="34" charset="0"/>
-                <a:ea typeface="Calibri" pitchFamily="34" charset="-122"/>
-                <a:cs typeface="Calibri" pitchFamily="34" charset="-120"/>
-              </a:rPr>
-              <a:t>  ·  Structured Finance Agent Framework</a:t>
-            </a:r>
-            <a:endParaRPr lang="en-US" sz="900" dirty="0"/>
-          </a:p>
-        </p:txBody>
-      </p:sp>
-      <p:sp>
-        <p:nvSpPr>
-          <p:cNvPr id="7" name="Text 5"/>
-          <p:cNvSpPr/>
-          <p:nvPr/>
-        </p:nvSpPr>
-        <p:spPr>
-          <a:xfrm>
-            <a:off x="10058400" y="6437376"/>
-            <a:ext cx="502920" cy="274320"/>
-          </a:xfrm>
-          <a:prstGeom prst="rect">
-            <a:avLst/>
-          </a:prstGeom>
-          <a:noFill/>
-          <a:ln/>
-        </p:spPr>
-        <p:txBody>
-          <a:bodyPr wrap="square" lIns="0" tIns="0" rIns="0" bIns="0" rtlCol="0" anchor="t"/>
-          <a:lstStyle/>
-          <a:p>
-            <a:pPr algn="r" indent="0" marL="0">
-              <a:lnSpc>
-                <a:spcPct val="100000"/>
-              </a:lnSpc>
-              <a:buNone/>
-            </a:pPr>
-            <a:r>
-              <a:rPr lang="en-US" sz="900" dirty="0">
-                <a:solidFill>
-                  <a:srgbClr val="6B7A90"/>
-                </a:solidFill>
-                <a:latin typeface="Calibri" pitchFamily="34" charset="0"/>
-                <a:ea typeface="Calibri" pitchFamily="34" charset="-122"/>
-                <a:cs typeface="Calibri" pitchFamily="34" charset="-120"/>
-              </a:rPr>
-              <a:t>06</a:t>
-            </a:r>
-            <a:endParaRPr lang="en-US" sz="900" dirty="0"/>
-          </a:p>
-        </p:txBody>
-      </p:sp>
-      <p:sp>
-        <p:nvSpPr>
-          <p:cNvPr id="8" name="Shape 6"/>
-          <p:cNvSpPr/>
-          <p:nvPr/>
-        </p:nvSpPr>
-        <p:spPr>
-          <a:xfrm>
-            <a:off x="640080" y="1828800"/>
-            <a:ext cx="3515258" cy="4297680"/>
-          </a:xfrm>
-          <a:prstGeom prst="roundRect">
-            <a:avLst>
-              <a:gd name="adj" fmla="val 1301"/>
-            </a:avLst>
-          </a:prstGeom>
-          <a:solidFill>
-            <a:srgbClr val="F4F7FB"/>
-          </a:solidFill>
-          <a:ln w="12700">
-            <a:solidFill>
-              <a:srgbClr val="DDE4EE"/>
-            </a:solidFill>
-            <a:prstDash val="solid"/>
-          </a:ln>
-          <a:effectLst>
-            <a:outerShdw sx="100000" sy="100000" kx="0" ky="0" algn="bl" rotWithShape="0" blurRad="88900" dist="38100" dir="5400000">
-              <a:srgbClr val="1B2A4A">
-                <a:alpha val="12000"/>
-              </a:srgbClr>
-            </a:outerShdw>
-          </a:effectLst>
-        </p:spPr>
-      </p:sp>
-      <p:sp>
-        <p:nvSpPr>
-          <p:cNvPr id="9" name="Shape 7"/>
-          <p:cNvSpPr/>
-          <p:nvPr/>
-        </p:nvSpPr>
-        <p:spPr>
-          <a:xfrm>
-            <a:off x="640080" y="1828800"/>
-            <a:ext cx="82296" cy="4297680"/>
-          </a:xfrm>
-          <a:prstGeom prst="rect">
-            <a:avLst/>
-          </a:prstGeom>
-          <a:solidFill>
-            <a:srgbClr val="2B59D6"/>
-          </a:solidFill>
-          <a:ln/>
-        </p:spPr>
-      </p:sp>
-      <p:sp>
-        <p:nvSpPr>
-          <p:cNvPr id="10" name="Text 8"/>
-          <p:cNvSpPr/>
-          <p:nvPr/>
-        </p:nvSpPr>
-        <p:spPr>
-          <a:xfrm>
-            <a:off x="896112" y="2029968"/>
-            <a:ext cx="3058058" cy="365760"/>
-          </a:xfrm>
-          <a:prstGeom prst="rect">
-            <a:avLst/>
-          </a:prstGeom>
-          <a:noFill/>
-          <a:ln/>
-        </p:spPr>
-        <p:txBody>
-          <a:bodyPr wrap="square" lIns="0" tIns="0" rIns="0" bIns="0" rtlCol="0" anchor="t"/>
-          <a:lstStyle/>
-          <a:p>
-            <a:pPr algn="l" indent="0" marL="0">
-              <a:lnSpc>
-                <a:spcPct val="100000"/>
-              </a:lnSpc>
-              <a:buNone/>
-            </a:pPr>
-            <a:r>
-              <a:rPr lang="en-US" sz="1500" b="1" dirty="0">
-                <a:solidFill>
-                  <a:srgbClr val="1B2A4A"/>
-                </a:solidFill>
-                <a:latin typeface="Calibri" pitchFamily="34" charset="0"/>
-                <a:ea typeface="Calibri" pitchFamily="34" charset="-122"/>
-                <a:cs typeface="Calibri" pitchFamily="34" charset="-120"/>
-              </a:rPr>
-              <a:t>MCP server</a:t>
-            </a:r>
-            <a:endParaRPr lang="en-US" sz="1500" dirty="0"/>
-          </a:p>
-        </p:txBody>
-      </p:sp>
-      <p:sp>
-        <p:nvSpPr>
-          <p:cNvPr id="11" name="Text 9"/>
-          <p:cNvSpPr/>
-          <p:nvPr/>
-        </p:nvSpPr>
-        <p:spPr>
-          <a:xfrm>
-            <a:off x="896112" y="2450592"/>
-            <a:ext cx="3012338" cy="3566160"/>
-          </a:xfrm>
-          <a:prstGeom prst="rect">
-            <a:avLst/>
-          </a:prstGeom>
-          <a:noFill/>
-          <a:ln/>
-        </p:spPr>
-        <p:txBody>
-          <a:bodyPr wrap="square" lIns="0" tIns="0" rIns="0" bIns="0" rtlCol="0" anchor="t"/>
-          <a:lstStyle/>
-          <a:p>
-            <a:pPr algn="l" indent="0" marL="0">
-              <a:lnSpc>
-                <a:spcPct val="106000"/>
-              </a:lnSpc>
-              <a:spcAft>
-                <a:spcPts val="300"/>
-              </a:spcAft>
-              <a:buNone/>
-            </a:pPr>
-            <a:r>
-              <a:rPr lang="en-US" sz="1250" dirty="0">
-                <a:solidFill>
-                  <a:srgbClr val="536177"/>
-                </a:solidFill>
-                <a:latin typeface="Calibri" pitchFamily="34" charset="0"/>
-                <a:ea typeface="Calibri" pitchFamily="34" charset="-122"/>
-                <a:cs typeface="Calibri" pitchFamily="34" charset="-120"/>
-              </a:rPr>
-              <a:t>The 8 SF primitives exposed as a governed MCP server — typed I/O + the evidence pack — consumable on any MCP host.</a:t>
-            </a:r>
-            <a:endParaRPr lang="en-US" sz="1250" dirty="0"/>
-          </a:p>
-        </p:txBody>
-      </p:sp>
-      <p:sp>
-        <p:nvSpPr>
-          <p:cNvPr id="12" name="Shape 10"/>
-          <p:cNvSpPr/>
-          <p:nvPr/>
-        </p:nvSpPr>
-        <p:spPr>
-          <a:xfrm>
-            <a:off x="4338218" y="1828800"/>
-            <a:ext cx="3515258" cy="4297680"/>
-          </a:xfrm>
-          <a:prstGeom prst="roundRect">
-            <a:avLst>
-              <a:gd name="adj" fmla="val 1301"/>
-            </a:avLst>
-          </a:prstGeom>
-          <a:solidFill>
-            <a:srgbClr val="F4F7FB"/>
-          </a:solidFill>
-          <a:ln w="12700">
-            <a:solidFill>
-              <a:srgbClr val="DDE4EE"/>
-            </a:solidFill>
-            <a:prstDash val="solid"/>
-          </a:ln>
-          <a:effectLst>
-            <a:outerShdw sx="100000" sy="100000" kx="0" ky="0" algn="bl" rotWithShape="0" blurRad="88900" dist="38100" dir="5400000">
-              <a:srgbClr val="1B2A4A">
-                <a:alpha val="12000"/>
-              </a:srgbClr>
-            </a:outerShdw>
-          </a:effectLst>
-        </p:spPr>
-      </p:sp>
-      <p:sp>
-        <p:nvSpPr>
-          <p:cNvPr id="13" name="Shape 11"/>
-          <p:cNvSpPr/>
-          <p:nvPr/>
-        </p:nvSpPr>
-        <p:spPr>
-          <a:xfrm>
-            <a:off x="4338218" y="1828800"/>
-            <a:ext cx="82296" cy="4297680"/>
-          </a:xfrm>
-          <a:prstGeom prst="rect">
-            <a:avLst/>
-          </a:prstGeom>
-          <a:solidFill>
-            <a:srgbClr val="129E8F"/>
-          </a:solidFill>
-          <a:ln/>
-        </p:spPr>
-      </p:sp>
-      <p:sp>
-        <p:nvSpPr>
-          <p:cNvPr id="14" name="Text 12"/>
-          <p:cNvSpPr/>
-          <p:nvPr/>
-        </p:nvSpPr>
-        <p:spPr>
-          <a:xfrm>
-            <a:off x="4594250" y="2029968"/>
-            <a:ext cx="3058058" cy="365760"/>
-          </a:xfrm>
-          <a:prstGeom prst="rect">
-            <a:avLst/>
-          </a:prstGeom>
-          <a:noFill/>
-          <a:ln/>
-        </p:spPr>
-        <p:txBody>
-          <a:bodyPr wrap="square" lIns="0" tIns="0" rIns="0" bIns="0" rtlCol="0" anchor="t"/>
-          <a:lstStyle/>
-          <a:p>
-            <a:pPr algn="l" indent="0" marL="0">
-              <a:lnSpc>
-                <a:spcPct val="100000"/>
-              </a:lnSpc>
-              <a:buNone/>
-            </a:pPr>
-            <a:r>
-              <a:rPr lang="en-US" sz="1500" b="1" dirty="0">
-                <a:solidFill>
-                  <a:srgbClr val="1B2A4A"/>
-                </a:solidFill>
-                <a:latin typeface="Calibri" pitchFamily="34" charset="0"/>
-                <a:ea typeface="Calibri" pitchFamily="34" charset="-122"/>
-                <a:cs typeface="Calibri" pitchFamily="34" charset="-120"/>
-              </a:rPr>
-              <a:t>Deal = data, not code</a:t>
-            </a:r>
-            <a:endParaRPr lang="en-US" sz="1500" dirty="0"/>
-          </a:p>
-        </p:txBody>
-      </p:sp>
-      <p:sp>
-        <p:nvSpPr>
-          <p:cNvPr id="15" name="Text 13"/>
-          <p:cNvSpPr/>
-          <p:nvPr/>
-        </p:nvSpPr>
-        <p:spPr>
-          <a:xfrm>
-            <a:off x="4594250" y="2450592"/>
-            <a:ext cx="3012338" cy="3566160"/>
-          </a:xfrm>
-          <a:prstGeom prst="rect">
-            <a:avLst/>
-          </a:prstGeom>
-          <a:noFill/>
-          <a:ln/>
-        </p:spPr>
-        <p:txBody>
-          <a:bodyPr wrap="square" lIns="0" tIns="0" rIns="0" bIns="0" rtlCol="0" anchor="t"/>
-          <a:lstStyle/>
-          <a:p>
-            <a:pPr algn="l" indent="0" marL="0">
-              <a:lnSpc>
-                <a:spcPct val="106000"/>
-              </a:lnSpc>
-              <a:spcAft>
-                <a:spcPts val="300"/>
-              </a:spcAft>
-              <a:buNone/>
-            </a:pPr>
-            <a:r>
-              <a:rPr lang="en-US" sz="1250" dirty="0">
-                <a:solidFill>
-                  <a:srgbClr val="536177"/>
-                </a:solidFill>
-                <a:latin typeface="Calibri" pitchFamily="34" charset="0"/>
-                <a:ea typeface="Calibri" pitchFamily="34" charset="-122"/>
-                <a:cs typeface="Calibri" pitchFamily="34" charset="-120"/>
-              </a:rPr>
-              <a:t>Add a deal by dropping JSON into deals.json; no Python. The interpreter executes the deal's extracted model, not hardcoded logic.</a:t>
-            </a:r>
-            <a:endParaRPr lang="en-US" sz="1250" dirty="0"/>
-          </a:p>
-        </p:txBody>
-      </p:sp>
-      <p:sp>
-        <p:nvSpPr>
-          <p:cNvPr id="16" name="Shape 14"/>
-          <p:cNvSpPr/>
-          <p:nvPr/>
-        </p:nvSpPr>
-        <p:spPr>
-          <a:xfrm>
-            <a:off x="8036357" y="1828800"/>
-            <a:ext cx="3515258" cy="4297680"/>
-          </a:xfrm>
-          <a:prstGeom prst="roundRect">
-            <a:avLst>
-              <a:gd name="adj" fmla="val 1301"/>
-            </a:avLst>
-          </a:prstGeom>
-          <a:solidFill>
-            <a:srgbClr val="F4F7FB"/>
-          </a:solidFill>
-          <a:ln w="12700">
-            <a:solidFill>
-              <a:srgbClr val="DDE4EE"/>
-            </a:solidFill>
-            <a:prstDash val="solid"/>
-          </a:ln>
-          <a:effectLst>
-            <a:outerShdw sx="100000" sy="100000" kx="0" ky="0" algn="bl" rotWithShape="0" blurRad="88900" dist="38100" dir="5400000">
-              <a:srgbClr val="1B2A4A">
-                <a:alpha val="12000"/>
-              </a:srgbClr>
-            </a:outerShdw>
-          </a:effectLst>
-        </p:spPr>
-      </p:sp>
-      <p:sp>
-        <p:nvSpPr>
-          <p:cNvPr id="17" name="Shape 15"/>
-          <p:cNvSpPr/>
-          <p:nvPr/>
-        </p:nvSpPr>
-        <p:spPr>
-          <a:xfrm>
-            <a:off x="8036357" y="1828800"/>
-            <a:ext cx="82296" cy="4297680"/>
-          </a:xfrm>
-          <a:prstGeom prst="rect">
-            <a:avLst/>
-          </a:prstGeom>
-          <a:solidFill>
-            <a:srgbClr val="1B2A4A"/>
-          </a:solidFill>
-          <a:ln/>
-        </p:spPr>
-      </p:sp>
-      <p:sp>
-        <p:nvSpPr>
-          <p:cNvPr id="18" name="Text 16"/>
-          <p:cNvSpPr/>
-          <p:nvPr/>
-        </p:nvSpPr>
-        <p:spPr>
-          <a:xfrm>
-            <a:off x="8292389" y="2029968"/>
-            <a:ext cx="3058058" cy="365760"/>
-          </a:xfrm>
-          <a:prstGeom prst="rect">
-            <a:avLst/>
-          </a:prstGeom>
-          <a:noFill/>
-          <a:ln/>
-        </p:spPr>
-        <p:txBody>
-          <a:bodyPr wrap="square" lIns="0" tIns="0" rIns="0" bIns="0" rtlCol="0" anchor="t"/>
-          <a:lstStyle/>
-          <a:p>
-            <a:pPr algn="l" indent="0" marL="0">
-              <a:lnSpc>
-                <a:spcPct val="100000"/>
-              </a:lnSpc>
-              <a:buNone/>
-            </a:pPr>
-            <a:r>
-              <a:rPr lang="en-US" sz="1500" b="1" dirty="0">
-                <a:solidFill>
-                  <a:srgbClr val="1B2A4A"/>
-                </a:solidFill>
-                <a:latin typeface="Calibri" pitchFamily="34" charset="0"/>
-                <a:ea typeface="Calibri" pitchFamily="34" charset="-122"/>
-                <a:cs typeface="Calibri" pitchFamily="34" charset="-120"/>
-              </a:rPr>
-              <a:t>Open &amp; portable</a:t>
-            </a:r>
-            <a:endParaRPr lang="en-US" sz="1500" dirty="0"/>
-          </a:p>
-        </p:txBody>
-      </p:sp>
-      <p:sp>
-        <p:nvSpPr>
-          <p:cNvPr id="19" name="Text 17"/>
-          <p:cNvSpPr/>
-          <p:nvPr/>
-        </p:nvSpPr>
-        <p:spPr>
-          <a:xfrm>
-            <a:off x="8292389" y="2450592"/>
-            <a:ext cx="3012338" cy="3566160"/>
-          </a:xfrm>
-          <a:prstGeom prst="rect">
-            <a:avLst/>
-          </a:prstGeom>
-          <a:noFill/>
-          <a:ln/>
-        </p:spPr>
-        <p:txBody>
-          <a:bodyPr wrap="square" lIns="0" tIns="0" rIns="0" bIns="0" rtlCol="0" anchor="t"/>
-          <a:lstStyle/>
-          <a:p>
-            <a:pPr algn="l" indent="0" marL="0">
-              <a:lnSpc>
-                <a:spcPct val="106000"/>
-              </a:lnSpc>
-              <a:spcAft>
-                <a:spcPts val="300"/>
-              </a:spcAft>
-              <a:buNone/>
-            </a:pPr>
-            <a:r>
-              <a:rPr lang="en-US" sz="1250" dirty="0">
-                <a:solidFill>
-                  <a:srgbClr val="536177"/>
-                </a:solidFill>
-                <a:latin typeface="Calibri" pitchFamily="34" charset="0"/>
-                <a:ea typeface="Calibri" pitchFamily="34" charset="-122"/>
-                <a:cs typeface="Calibri" pitchFamily="34" charset="-120"/>
-              </a:rPr>
-              <a:t>Apache-2.0; CSV or parquet tapes; deeploans (Algoritmica's ESMA ETL) on the ingestion path with a direct fallback.</a:t>
-            </a:r>
-            <a:endParaRPr lang="en-US" sz="1250" dirty="0"/>
           </a:p>
         </p:txBody>
       </p:sp>
@@ -6894,7 +7386,7 @@
                 <a:ea typeface="Calibri" pitchFamily="34" charset="-122"/>
                 <a:cs typeface="Calibri" pitchFamily="34" charset="-120"/>
               </a:rPr>
-              <a:t>TRUST — FINOS AI GOVERNANCE FRAMEWORK + DEEPLOANS</a:t>
+              <a:t>PACKAGED FOR REUSE</a:t>
             </a:r>
             <a:endParaRPr lang="en-US" sz="1200" dirty="0"/>
           </a:p>
@@ -6936,7 +7428,7 @@
                 <a:ea typeface="Calibri" pitchFamily="34" charset="-122"/>
                 <a:cs typeface="Calibri" pitchFamily="34" charset="-120"/>
               </a:rPr>
-              <a:t>Governance is baked into the interface</a:t>
+              <a:t>Reusable infrastructure, not a one-off</a:t>
             </a:r>
             <a:endParaRPr lang="en-US" sz="2800" dirty="0"/>
           </a:p>
@@ -7072,11 +7564,11 @@
         <p:spPr>
           <a:xfrm>
             <a:off x="640080" y="1828800"/>
-            <a:ext cx="3515258" cy="2066544"/>
+            <a:ext cx="3515258" cy="4297680"/>
           </a:xfrm>
           <a:prstGeom prst="roundRect">
             <a:avLst>
-              <a:gd name="adj" fmla="val 2212"/>
+              <a:gd name="adj" fmla="val 1301"/>
             </a:avLst>
           </a:prstGeom>
           <a:solidFill>
@@ -7106,7 +7598,7 @@
         <p:spPr>
           <a:xfrm>
             <a:off x="640080" y="1828800"/>
-            <a:ext cx="82296" cy="2066544"/>
+            <a:ext cx="82296" cy="4297680"/>
           </a:xfrm>
           <a:prstGeom prst="rect">
             <a:avLst/>
@@ -7153,7 +7645,7 @@
                 <a:ea typeface="Calibri" pitchFamily="34" charset="-122"/>
                 <a:cs typeface="Calibri" pitchFamily="34" charset="-120"/>
               </a:rPr>
-              <a:t>Audit trail</a:t>
+              <a:t>MCP server</a:t>
             </a:r>
             <a:endParaRPr lang="en-US" sz="1500" dirty="0"/>
           </a:p>
@@ -7168,7 +7660,7 @@
         <p:spPr>
           <a:xfrm>
             <a:off x="896112" y="2450592"/>
-            <a:ext cx="3012338" cy="1335024"/>
+            <a:ext cx="3012338" cy="3566160"/>
           </a:xfrm>
           <a:prstGeom prst="rect">
             <a:avLst/>
@@ -7198,7 +7690,7 @@
                 <a:ea typeface="Calibri" pitchFamily="34" charset="-122"/>
                 <a:cs typeface="Calibri" pitchFamily="34" charset="-120"/>
               </a:rPr>
-              <a:t>Append-only entry per call: hashes, model version, timestamp, duration.</a:t>
+              <a:t>All 9 SF primitives — including the prospectus parser itself — exposed as a governed MCP server with typed I/O + the evidence pack, consumable on any MCP host.</a:t>
             </a:r>
             <a:endParaRPr lang="en-US" sz="1250" dirty="0"/>
           </a:p>
@@ -7213,11 +7705,11 @@
         <p:spPr>
           <a:xfrm>
             <a:off x="4338218" y="1828800"/>
-            <a:ext cx="3515258" cy="2066544"/>
+            <a:ext cx="3515258" cy="4297680"/>
           </a:xfrm>
           <a:prstGeom prst="roundRect">
             <a:avLst>
-              <a:gd name="adj" fmla="val 2212"/>
+              <a:gd name="adj" fmla="val 1301"/>
             </a:avLst>
           </a:prstGeom>
           <a:solidFill>
@@ -7247,13 +7739,13 @@
         <p:spPr>
           <a:xfrm>
             <a:off x="4338218" y="1828800"/>
-            <a:ext cx="82296" cy="2066544"/>
+            <a:ext cx="82296" cy="4297680"/>
           </a:xfrm>
           <a:prstGeom prst="rect">
             <a:avLst/>
           </a:prstGeom>
           <a:solidFill>
-            <a:srgbClr val="2B59D6"/>
+            <a:srgbClr val="129E8F"/>
           </a:solidFill>
           <a:ln/>
         </p:spPr>
@@ -7294,7 +7786,7 @@
                 <a:ea typeface="Calibri" pitchFamily="34" charset="-122"/>
                 <a:cs typeface="Calibri" pitchFamily="34" charset="-120"/>
               </a:rPr>
-              <a:t>Confidence scoring</a:t>
+              <a:t>Deal = data, not code</a:t>
             </a:r>
             <a:endParaRPr lang="en-US" sz="1500" dirty="0"/>
           </a:p>
@@ -7309,7 +7801,7 @@
         <p:spPr>
           <a:xfrm>
             <a:off x="4594250" y="2450592"/>
-            <a:ext cx="3012338" cy="1335024"/>
+            <a:ext cx="3012338" cy="3566160"/>
           </a:xfrm>
           <a:prstGeom prst="rect">
             <a:avLst/>
@@ -7339,7 +7831,7 @@
                 <a:ea typeface="Calibri" pitchFamily="34" charset="-122"/>
                 <a:cs typeface="Calibri" pitchFamily="34" charset="-120"/>
               </a:rPr>
-              <a:t>Mandatory on every primitive — coverage · cross-ref · self-assessment.</a:t>
+              <a:t>Add a deal by dropping JSON into deals.json; no Python. The interpreter executes the deal's extracted model, not hardcoded logic.</a:t>
             </a:r>
             <a:endParaRPr lang="en-US" sz="1250" dirty="0"/>
           </a:p>
@@ -7354,11 +7846,11 @@
         <p:spPr>
           <a:xfrm>
             <a:off x="8036357" y="1828800"/>
-            <a:ext cx="3515258" cy="2066544"/>
+            <a:ext cx="3515258" cy="4297680"/>
           </a:xfrm>
           <a:prstGeom prst="roundRect">
             <a:avLst>
-              <a:gd name="adj" fmla="val 2212"/>
+              <a:gd name="adj" fmla="val 1301"/>
             </a:avLst>
           </a:prstGeom>
           <a:solidFill>
@@ -7388,13 +7880,13 @@
         <p:spPr>
           <a:xfrm>
             <a:off x="8036357" y="1828800"/>
-            <a:ext cx="82296" cy="2066544"/>
+            <a:ext cx="82296" cy="4297680"/>
           </a:xfrm>
           <a:prstGeom prst="rect">
             <a:avLst/>
           </a:prstGeom>
           <a:solidFill>
-            <a:srgbClr val="2B59D6"/>
+            <a:srgbClr val="1B2A4A"/>
           </a:solidFill>
           <a:ln/>
         </p:spPr>
@@ -7435,7 +7927,7 @@
                 <a:ea typeface="Calibri" pitchFamily="34" charset="-122"/>
                 <a:cs typeface="Calibri" pitchFamily="34" charset="-120"/>
               </a:rPr>
-              <a:t>Verbatim citations</a:t>
+              <a:t>Open &amp; portable</a:t>
             </a:r>
             <a:endParaRPr lang="en-US" sz="1500" dirty="0"/>
           </a:p>
@@ -7450,7 +7942,7 @@
         <p:spPr>
           <a:xfrm>
             <a:off x="8292389" y="2450592"/>
-            <a:ext cx="3012338" cy="1335024"/>
+            <a:ext cx="3012338" cy="3566160"/>
           </a:xfrm>
           <a:prstGeom prst="rect">
             <a:avLst/>
@@ -7480,430 +7972,7 @@
                 <a:ea typeface="Calibri" pitchFamily="34" charset="-122"/>
                 <a:cs typeface="Calibri" pitchFamily="34" charset="-120"/>
               </a:rPr>
-              <a:t>Every fact grounded to a section + excerpt a reviewer can locate.</a:t>
-            </a:r>
-            <a:endParaRPr lang="en-US" sz="1250" dirty="0"/>
-          </a:p>
-        </p:txBody>
-      </p:sp>
-      <p:sp>
-        <p:nvSpPr>
-          <p:cNvPr id="20" name="Shape 18"/>
-          <p:cNvSpPr/>
-          <p:nvPr/>
-        </p:nvSpPr>
-        <p:spPr>
-          <a:xfrm>
-            <a:off x="640080" y="4059936"/>
-            <a:ext cx="3515258" cy="2066544"/>
-          </a:xfrm>
-          <a:prstGeom prst="roundRect">
-            <a:avLst>
-              <a:gd name="adj" fmla="val 2212"/>
-            </a:avLst>
-          </a:prstGeom>
-          <a:solidFill>
-            <a:srgbClr val="F4F7FB"/>
-          </a:solidFill>
-          <a:ln w="12700">
-            <a:solidFill>
-              <a:srgbClr val="DDE4EE"/>
-            </a:solidFill>
-            <a:prstDash val="solid"/>
-          </a:ln>
-          <a:effectLst>
-            <a:outerShdw sx="100000" sy="100000" kx="0" ky="0" algn="bl" rotWithShape="0" blurRad="88900" dist="38100" dir="5400000">
-              <a:srgbClr val="1B2A4A">
-                <a:alpha val="12000"/>
-              </a:srgbClr>
-            </a:outerShdw>
-          </a:effectLst>
-        </p:spPr>
-      </p:sp>
-      <p:sp>
-        <p:nvSpPr>
-          <p:cNvPr id="21" name="Shape 19"/>
-          <p:cNvSpPr/>
-          <p:nvPr/>
-        </p:nvSpPr>
-        <p:spPr>
-          <a:xfrm>
-            <a:off x="640080" y="4059936"/>
-            <a:ext cx="82296" cy="2066544"/>
-          </a:xfrm>
-          <a:prstGeom prst="rect">
-            <a:avLst/>
-          </a:prstGeom>
-          <a:solidFill>
-            <a:srgbClr val="2B59D6"/>
-          </a:solidFill>
-          <a:ln/>
-        </p:spPr>
-      </p:sp>
-      <p:sp>
-        <p:nvSpPr>
-          <p:cNvPr id="22" name="Text 20"/>
-          <p:cNvSpPr/>
-          <p:nvPr/>
-        </p:nvSpPr>
-        <p:spPr>
-          <a:xfrm>
-            <a:off x="896112" y="4261104"/>
-            <a:ext cx="3058058" cy="365760"/>
-          </a:xfrm>
-          <a:prstGeom prst="rect">
-            <a:avLst/>
-          </a:prstGeom>
-          <a:noFill/>
-          <a:ln/>
-        </p:spPr>
-        <p:txBody>
-          <a:bodyPr wrap="square" lIns="0" tIns="0" rIns="0" bIns="0" rtlCol="0" anchor="t"/>
-          <a:lstStyle/>
-          <a:p>
-            <a:pPr algn="l" indent="0" marL="0">
-              <a:lnSpc>
-                <a:spcPct val="100000"/>
-              </a:lnSpc>
-              <a:buNone/>
-            </a:pPr>
-            <a:r>
-              <a:rPr lang="en-US" sz="1500" b="1" dirty="0">
-                <a:solidFill>
-                  <a:srgbClr val="1B2A4A"/>
-                </a:solidFill>
-                <a:latin typeface="Calibri" pitchFamily="34" charset="0"/>
-                <a:ea typeface="Calibri" pitchFamily="34" charset="-122"/>
-                <a:cs typeface="Calibri" pitchFamily="34" charset="-120"/>
-              </a:rPr>
-              <a:t>Data provenance</a:t>
-            </a:r>
-            <a:endParaRPr lang="en-US" sz="1500" dirty="0"/>
-          </a:p>
-        </p:txBody>
-      </p:sp>
-      <p:sp>
-        <p:nvSpPr>
-          <p:cNvPr id="23" name="Text 21"/>
-          <p:cNvSpPr/>
-          <p:nvPr/>
-        </p:nvSpPr>
-        <p:spPr>
-          <a:xfrm>
-            <a:off x="896112" y="4681728"/>
-            <a:ext cx="3012338" cy="1335024"/>
-          </a:xfrm>
-          <a:prstGeom prst="rect">
-            <a:avLst/>
-          </a:prstGeom>
-          <a:noFill/>
-          <a:ln/>
-        </p:spPr>
-        <p:txBody>
-          <a:bodyPr wrap="square" lIns="0" tIns="0" rIns="0" bIns="0" rtlCol="0" anchor="t"/>
-          <a:lstStyle/>
-          <a:p>
-            <a:pPr algn="l" indent="0" marL="0">
-              <a:lnSpc>
-                <a:spcPct val="106000"/>
-              </a:lnSpc>
-              <a:spcAft>
-                <a:spcPts val="300"/>
-              </a:spcAft>
-              <a:buNone/>
-            </a:pPr>
-            <a:r>
-              <a:rPr lang="en-US" sz="1250" dirty="0">
-                <a:solidFill>
-                  <a:srgbClr val="536177"/>
-                </a:solidFill>
-                <a:latin typeface="Calibri" pitchFamily="34" charset="0"/>
-                <a:ea typeface="Calibri" pitchFamily="34" charset="-122"/>
-                <a:cs typeface="Calibri" pitchFamily="34" charset="-120"/>
-              </a:rPr>
-              <a:t>Each tape tagged deeploans vs direct, carried into the evidence pack.</a:t>
-            </a:r>
-            <a:endParaRPr lang="en-US" sz="1250" dirty="0"/>
-          </a:p>
-        </p:txBody>
-      </p:sp>
-      <p:sp>
-        <p:nvSpPr>
-          <p:cNvPr id="24" name="Shape 22"/>
-          <p:cNvSpPr/>
-          <p:nvPr/>
-        </p:nvSpPr>
-        <p:spPr>
-          <a:xfrm>
-            <a:off x="4338218" y="4059936"/>
-            <a:ext cx="3515258" cy="2066544"/>
-          </a:xfrm>
-          <a:prstGeom prst="roundRect">
-            <a:avLst>
-              <a:gd name="adj" fmla="val 2212"/>
-            </a:avLst>
-          </a:prstGeom>
-          <a:solidFill>
-            <a:srgbClr val="F4F7FB"/>
-          </a:solidFill>
-          <a:ln w="12700">
-            <a:solidFill>
-              <a:srgbClr val="DDE4EE"/>
-            </a:solidFill>
-            <a:prstDash val="solid"/>
-          </a:ln>
-          <a:effectLst>
-            <a:outerShdw sx="100000" sy="100000" kx="0" ky="0" algn="bl" rotWithShape="0" blurRad="88900" dist="38100" dir="5400000">
-              <a:srgbClr val="1B2A4A">
-                <a:alpha val="12000"/>
-              </a:srgbClr>
-            </a:outerShdw>
-          </a:effectLst>
-        </p:spPr>
-      </p:sp>
-      <p:sp>
-        <p:nvSpPr>
-          <p:cNvPr id="25" name="Shape 23"/>
-          <p:cNvSpPr/>
-          <p:nvPr/>
-        </p:nvSpPr>
-        <p:spPr>
-          <a:xfrm>
-            <a:off x="4338218" y="4059936"/>
-            <a:ext cx="82296" cy="2066544"/>
-          </a:xfrm>
-          <a:prstGeom prst="rect">
-            <a:avLst/>
-          </a:prstGeom>
-          <a:solidFill>
-            <a:srgbClr val="2B59D6"/>
-          </a:solidFill>
-          <a:ln/>
-        </p:spPr>
-      </p:sp>
-      <p:sp>
-        <p:nvSpPr>
-          <p:cNvPr id="26" name="Text 24"/>
-          <p:cNvSpPr/>
-          <p:nvPr/>
-        </p:nvSpPr>
-        <p:spPr>
-          <a:xfrm>
-            <a:off x="4594250" y="4261104"/>
-            <a:ext cx="3058058" cy="365760"/>
-          </a:xfrm>
-          <a:prstGeom prst="rect">
-            <a:avLst/>
-          </a:prstGeom>
-          <a:noFill/>
-          <a:ln/>
-        </p:spPr>
-        <p:txBody>
-          <a:bodyPr wrap="square" lIns="0" tIns="0" rIns="0" bIns="0" rtlCol="0" anchor="t"/>
-          <a:lstStyle/>
-          <a:p>
-            <a:pPr algn="l" indent="0" marL="0">
-              <a:lnSpc>
-                <a:spcPct val="100000"/>
-              </a:lnSpc>
-              <a:buNone/>
-            </a:pPr>
-            <a:r>
-              <a:rPr lang="en-US" sz="1500" b="1" dirty="0">
-                <a:solidFill>
-                  <a:srgbClr val="1B2A4A"/>
-                </a:solidFill>
-                <a:latin typeface="Calibri" pitchFamily="34" charset="0"/>
-                <a:ea typeface="Calibri" pitchFamily="34" charset="-122"/>
-                <a:cs typeface="Calibri" pitchFamily="34" charset="-120"/>
-              </a:rPr>
-              <a:t>Human-review routing</a:t>
-            </a:r>
-            <a:endParaRPr lang="en-US" sz="1500" dirty="0"/>
-          </a:p>
-        </p:txBody>
-      </p:sp>
-      <p:sp>
-        <p:nvSpPr>
-          <p:cNvPr id="27" name="Text 25"/>
-          <p:cNvSpPr/>
-          <p:nvPr/>
-        </p:nvSpPr>
-        <p:spPr>
-          <a:xfrm>
-            <a:off x="4594250" y="4681728"/>
-            <a:ext cx="3012338" cy="1335024"/>
-          </a:xfrm>
-          <a:prstGeom prst="rect">
-            <a:avLst/>
-          </a:prstGeom>
-          <a:noFill/>
-          <a:ln/>
-        </p:spPr>
-        <p:txBody>
-          <a:bodyPr wrap="square" lIns="0" tIns="0" rIns="0" bIns="0" rtlCol="0" anchor="t"/>
-          <a:lstStyle/>
-          <a:p>
-            <a:pPr algn="l" indent="0" marL="0">
-              <a:lnSpc>
-                <a:spcPct val="106000"/>
-              </a:lnSpc>
-              <a:spcAft>
-                <a:spcPts val="300"/>
-              </a:spcAft>
-              <a:buNone/>
-            </a:pPr>
-            <a:r>
-              <a:rPr lang="en-US" sz="1250" dirty="0">
-                <a:solidFill>
-                  <a:srgbClr val="536177"/>
-                </a:solidFill>
-                <a:latin typeface="Calibri" pitchFamily="34" charset="0"/>
-                <a:ea typeface="Calibri" pitchFamily="34" charset="-122"/>
-                <a:cs typeface="Calibri" pitchFamily="34" charset="-120"/>
-              </a:rPr>
-              <a:t>Confidence &lt; 0.70 → flagged; output can't be used until signed off.</a:t>
-            </a:r>
-            <a:endParaRPr lang="en-US" sz="1250" dirty="0"/>
-          </a:p>
-        </p:txBody>
-      </p:sp>
-      <p:sp>
-        <p:nvSpPr>
-          <p:cNvPr id="28" name="Shape 26"/>
-          <p:cNvSpPr/>
-          <p:nvPr/>
-        </p:nvSpPr>
-        <p:spPr>
-          <a:xfrm>
-            <a:off x="8036357" y="4059936"/>
-            <a:ext cx="3515258" cy="2066544"/>
-          </a:xfrm>
-          <a:prstGeom prst="roundRect">
-            <a:avLst>
-              <a:gd name="adj" fmla="val 2212"/>
-            </a:avLst>
-          </a:prstGeom>
-          <a:solidFill>
-            <a:srgbClr val="F4F7FB"/>
-          </a:solidFill>
-          <a:ln w="12700">
-            <a:solidFill>
-              <a:srgbClr val="DDE4EE"/>
-            </a:solidFill>
-            <a:prstDash val="solid"/>
-          </a:ln>
-          <a:effectLst>
-            <a:outerShdw sx="100000" sy="100000" kx="0" ky="0" algn="bl" rotWithShape="0" blurRad="88900" dist="38100" dir="5400000">
-              <a:srgbClr val="1B2A4A">
-                <a:alpha val="12000"/>
-              </a:srgbClr>
-            </a:outerShdw>
-          </a:effectLst>
-        </p:spPr>
-      </p:sp>
-      <p:sp>
-        <p:nvSpPr>
-          <p:cNvPr id="29" name="Shape 27"/>
-          <p:cNvSpPr/>
-          <p:nvPr/>
-        </p:nvSpPr>
-        <p:spPr>
-          <a:xfrm>
-            <a:off x="8036357" y="4059936"/>
-            <a:ext cx="82296" cy="2066544"/>
-          </a:xfrm>
-          <a:prstGeom prst="rect">
-            <a:avLst/>
-          </a:prstGeom>
-          <a:solidFill>
-            <a:srgbClr val="2B59D6"/>
-          </a:solidFill>
-          <a:ln/>
-        </p:spPr>
-      </p:sp>
-      <p:sp>
-        <p:nvSpPr>
-          <p:cNvPr id="30" name="Text 28"/>
-          <p:cNvSpPr/>
-          <p:nvPr/>
-        </p:nvSpPr>
-        <p:spPr>
-          <a:xfrm>
-            <a:off x="8292389" y="4261104"/>
-            <a:ext cx="3058058" cy="365760"/>
-          </a:xfrm>
-          <a:prstGeom prst="rect">
-            <a:avLst/>
-          </a:prstGeom>
-          <a:noFill/>
-          <a:ln/>
-        </p:spPr>
-        <p:txBody>
-          <a:bodyPr wrap="square" lIns="0" tIns="0" rIns="0" bIns="0" rtlCol="0" anchor="t"/>
-          <a:lstStyle/>
-          <a:p>
-            <a:pPr algn="l" indent="0" marL="0">
-              <a:lnSpc>
-                <a:spcPct val="100000"/>
-              </a:lnSpc>
-              <a:buNone/>
-            </a:pPr>
-            <a:r>
-              <a:rPr lang="en-US" sz="1500" b="1" dirty="0">
-                <a:solidFill>
-                  <a:srgbClr val="1B2A4A"/>
-                </a:solidFill>
-                <a:latin typeface="Calibri" pitchFamily="34" charset="0"/>
-                <a:ea typeface="Calibri" pitchFamily="34" charset="-122"/>
-                <a:cs typeface="Calibri" pitchFamily="34" charset="-120"/>
-              </a:rPr>
-              <a:t>Model-risk class</a:t>
-            </a:r>
-            <a:endParaRPr lang="en-US" sz="1500" dirty="0"/>
-          </a:p>
-        </p:txBody>
-      </p:sp>
-      <p:sp>
-        <p:nvSpPr>
-          <p:cNvPr id="31" name="Text 29"/>
-          <p:cNvSpPr/>
-          <p:nvPr/>
-        </p:nvSpPr>
-        <p:spPr>
-          <a:xfrm>
-            <a:off x="8292389" y="4681728"/>
-            <a:ext cx="3012338" cy="1335024"/>
-          </a:xfrm>
-          <a:prstGeom prst="rect">
-            <a:avLst/>
-          </a:prstGeom>
-          <a:noFill/>
-          <a:ln/>
-        </p:spPr>
-        <p:txBody>
-          <a:bodyPr wrap="square" lIns="0" tIns="0" rIns="0" bIns="0" rtlCol="0" anchor="t"/>
-          <a:lstStyle/>
-          <a:p>
-            <a:pPr algn="l" indent="0" marL="0">
-              <a:lnSpc>
-                <a:spcPct val="106000"/>
-              </a:lnSpc>
-              <a:spcAft>
-                <a:spcPts val="300"/>
-              </a:spcAft>
-              <a:buNone/>
-            </a:pPr>
-            <a:r>
-              <a:rPr lang="en-US" sz="1250" dirty="0">
-                <a:solidFill>
-                  <a:srgbClr val="536177"/>
-                </a:solidFill>
-                <a:latin typeface="Calibri" pitchFamily="34" charset="0"/>
-                <a:ea typeface="Calibri" pitchFamily="34" charset="-122"/>
-                <a:cs typeface="Calibri" pitchFamily="34" charset="-120"/>
-              </a:rPr>
-              <a:t>Decision-support tier, zero autonomy — outputs are inputs, never actions.</a:t>
+              <a:t>Apache-2.0; CSV or parquet tapes; either deeploans (Algoritmica's ESMA ETL) or a direct read — selectable per deal. This demo runs direct; the deeploans path is wired but its backend isn't stood up here.</a:t>
             </a:r>
             <a:endParaRPr lang="en-US" sz="1250" dirty="0"/>
           </a:p>
@@ -7997,7 +8066,7 @@
                 <a:ea typeface="Calibri" pitchFamily="34" charset="-122"/>
                 <a:cs typeface="Calibri" pitchFamily="34" charset="-120"/>
               </a:rPr>
-              <a:t>WHAT WE BUILT — THE DASHBOARD</a:t>
+              <a:t>TRUST — FINOS AI GOVERNANCE FRAMEWORK + DEEPLOANS</a:t>
             </a:r>
             <a:endParaRPr lang="en-US" sz="1200" dirty="0"/>
           </a:p>
@@ -8039,7 +8108,7 @@
                 <a:ea typeface="Calibri" pitchFamily="34" charset="-122"/>
                 <a:cs typeface="Calibri" pitchFamily="34" charset="-120"/>
               </a:rPr>
-              <a:t>Two layers, one product</a:t>
+              <a:t>Governance is baked into the interface</a:t>
             </a:r>
             <a:endParaRPr lang="en-US" sz="2800" dirty="0"/>
           </a:p>
@@ -8175,11 +8244,11 @@
         <p:spPr>
           <a:xfrm>
             <a:off x="640080" y="1828800"/>
-            <a:ext cx="5364328" cy="4297680"/>
+            <a:ext cx="3515258" cy="2066544"/>
           </a:xfrm>
           <a:prstGeom prst="roundRect">
             <a:avLst>
-              <a:gd name="adj" fmla="val 1064"/>
+              <a:gd name="adj" fmla="val 2212"/>
             </a:avLst>
           </a:prstGeom>
           <a:solidFill>
@@ -8209,13 +8278,13 @@
         <p:spPr>
           <a:xfrm>
             <a:off x="640080" y="1828800"/>
-            <a:ext cx="82296" cy="4297680"/>
+            <a:ext cx="82296" cy="2066544"/>
           </a:xfrm>
           <a:prstGeom prst="rect">
             <a:avLst/>
           </a:prstGeom>
           <a:solidFill>
-            <a:srgbClr val="1B2A4A"/>
+            <a:srgbClr val="2B59D6"/>
           </a:solidFill>
           <a:ln/>
         </p:spPr>
@@ -8229,7 +8298,7 @@
         <p:spPr>
           <a:xfrm>
             <a:off x="896112" y="2029968"/>
-            <a:ext cx="4907128" cy="365760"/>
+            <a:ext cx="3058058" cy="365760"/>
           </a:xfrm>
           <a:prstGeom prst="rect">
             <a:avLst/>
@@ -8256,7 +8325,7 @@
                 <a:ea typeface="Calibri" pitchFamily="34" charset="-122"/>
                 <a:cs typeface="Calibri" pitchFamily="34" charset="-120"/>
               </a:rPr>
-              <a:t>Deal Analytics</a:t>
+              <a:t>Audit trail</a:t>
             </a:r>
             <a:endParaRPr lang="en-US" sz="1500" dirty="0"/>
           </a:p>
@@ -8271,7 +8340,7 @@
         <p:spPr>
           <a:xfrm>
             <a:off x="896112" y="2450592"/>
-            <a:ext cx="4861408" cy="3566160"/>
+            <a:ext cx="3012338" cy="1335024"/>
           </a:xfrm>
           <a:prstGeom prst="rect">
             <a:avLst/>
@@ -8301,7 +8370,7 @@
                 <a:ea typeface="Calibri" pitchFamily="34" charset="-122"/>
                 <a:cs typeface="Calibri" pitchFamily="34" charset="-120"/>
               </a:rPr>
-              <a:t>Overview · Pool &amp; Performance · Waterfall · Compliance · Projection — the per-deal analyst workflow over the extracted model.</a:t>
+              <a:t>Append-only entry per call: hashes, model version, timestamp, duration.</a:t>
             </a:r>
             <a:endParaRPr lang="en-US" sz="1250" dirty="0"/>
           </a:p>
@@ -8315,12 +8384,12 @@
         </p:nvSpPr>
         <p:spPr>
           <a:xfrm>
-            <a:off x="6187288" y="1828800"/>
-            <a:ext cx="5364328" cy="4297680"/>
+            <a:off x="4338218" y="1828800"/>
+            <a:ext cx="3515258" cy="2066544"/>
           </a:xfrm>
           <a:prstGeom prst="roundRect">
             <a:avLst>
-              <a:gd name="adj" fmla="val 1064"/>
+              <a:gd name="adj" fmla="val 2212"/>
             </a:avLst>
           </a:prstGeom>
           <a:solidFill>
@@ -8349,8 +8418,8 @@
         </p:nvSpPr>
         <p:spPr>
           <a:xfrm>
-            <a:off x="6187288" y="1828800"/>
-            <a:ext cx="82296" cy="4297680"/>
+            <a:off x="4338218" y="1828800"/>
+            <a:ext cx="82296" cy="2066544"/>
           </a:xfrm>
           <a:prstGeom prst="rect">
             <a:avLst/>
@@ -8369,8 +8438,8 @@
         </p:nvSpPr>
         <p:spPr>
           <a:xfrm>
-            <a:off x="6443320" y="2029968"/>
-            <a:ext cx="4907128" cy="365760"/>
+            <a:off x="4594250" y="2029968"/>
+            <a:ext cx="3058058" cy="365760"/>
           </a:xfrm>
           <a:prstGeom prst="rect">
             <a:avLst/>
@@ -8397,7 +8466,7 @@
                 <a:ea typeface="Calibri" pitchFamily="34" charset="-122"/>
                 <a:cs typeface="Calibri" pitchFamily="34" charset="-120"/>
               </a:rPr>
-              <a:t>Platform &amp; Governance</a:t>
+              <a:t>Confidence scoring</a:t>
             </a:r>
             <a:endParaRPr lang="en-US" sz="1500" dirty="0"/>
           </a:p>
@@ -8411,8 +8480,8 @@
         </p:nvSpPr>
         <p:spPr>
           <a:xfrm>
-            <a:off x="6443320" y="2450592"/>
-            <a:ext cx="4861408" cy="3566160"/>
+            <a:off x="4594250" y="2450592"/>
+            <a:ext cx="3012338" cy="1335024"/>
           </a:xfrm>
           <a:prstGeom prst="rect">
             <a:avLst/>
@@ -8442,7 +8511,571 @@
                 <a:ea typeface="Calibri" pitchFamily="34" charset="-122"/>
                 <a:cs typeface="Calibri" pitchFamily="34" charset="-120"/>
               </a:rPr>
-              <a:t>Showcase · Validation · Framework · Governance — the cross-deal, trust &amp; reusability layer that headlines the work.</a:t>
+              <a:t>Mandatory on every primitive — coverage · cross-ref · self-assessment.</a:t>
+            </a:r>
+            <a:endParaRPr lang="en-US" sz="1250" dirty="0"/>
+          </a:p>
+        </p:txBody>
+      </p:sp>
+      <p:sp>
+        <p:nvSpPr>
+          <p:cNvPr id="16" name="Shape 14"/>
+          <p:cNvSpPr/>
+          <p:nvPr/>
+        </p:nvSpPr>
+        <p:spPr>
+          <a:xfrm>
+            <a:off x="8036357" y="1828800"/>
+            <a:ext cx="3515258" cy="2066544"/>
+          </a:xfrm>
+          <a:prstGeom prst="roundRect">
+            <a:avLst>
+              <a:gd name="adj" fmla="val 2212"/>
+            </a:avLst>
+          </a:prstGeom>
+          <a:solidFill>
+            <a:srgbClr val="F4F7FB"/>
+          </a:solidFill>
+          <a:ln w="12700">
+            <a:solidFill>
+              <a:srgbClr val="DDE4EE"/>
+            </a:solidFill>
+            <a:prstDash val="solid"/>
+          </a:ln>
+          <a:effectLst>
+            <a:outerShdw sx="100000" sy="100000" kx="0" ky="0" algn="bl" rotWithShape="0" blurRad="88900" dist="38100" dir="5400000">
+              <a:srgbClr val="1B2A4A">
+                <a:alpha val="12000"/>
+              </a:srgbClr>
+            </a:outerShdw>
+          </a:effectLst>
+        </p:spPr>
+      </p:sp>
+      <p:sp>
+        <p:nvSpPr>
+          <p:cNvPr id="17" name="Shape 15"/>
+          <p:cNvSpPr/>
+          <p:nvPr/>
+        </p:nvSpPr>
+        <p:spPr>
+          <a:xfrm>
+            <a:off x="8036357" y="1828800"/>
+            <a:ext cx="82296" cy="2066544"/>
+          </a:xfrm>
+          <a:prstGeom prst="rect">
+            <a:avLst/>
+          </a:prstGeom>
+          <a:solidFill>
+            <a:srgbClr val="2B59D6"/>
+          </a:solidFill>
+          <a:ln/>
+        </p:spPr>
+      </p:sp>
+      <p:sp>
+        <p:nvSpPr>
+          <p:cNvPr id="18" name="Text 16"/>
+          <p:cNvSpPr/>
+          <p:nvPr/>
+        </p:nvSpPr>
+        <p:spPr>
+          <a:xfrm>
+            <a:off x="8292389" y="2029968"/>
+            <a:ext cx="3058058" cy="365760"/>
+          </a:xfrm>
+          <a:prstGeom prst="rect">
+            <a:avLst/>
+          </a:prstGeom>
+          <a:noFill/>
+          <a:ln/>
+        </p:spPr>
+        <p:txBody>
+          <a:bodyPr wrap="square" lIns="0" tIns="0" rIns="0" bIns="0" rtlCol="0" anchor="t"/>
+          <a:lstStyle/>
+          <a:p>
+            <a:pPr algn="l" indent="0" marL="0">
+              <a:lnSpc>
+                <a:spcPct val="100000"/>
+              </a:lnSpc>
+              <a:buNone/>
+            </a:pPr>
+            <a:r>
+              <a:rPr lang="en-US" sz="1500" b="1" dirty="0">
+                <a:solidFill>
+                  <a:srgbClr val="1B2A4A"/>
+                </a:solidFill>
+                <a:latin typeface="Calibri" pitchFamily="34" charset="0"/>
+                <a:ea typeface="Calibri" pitchFamily="34" charset="-122"/>
+                <a:cs typeface="Calibri" pitchFamily="34" charset="-120"/>
+              </a:rPr>
+              <a:t>Verbatim citations</a:t>
+            </a:r>
+            <a:endParaRPr lang="en-US" sz="1500" dirty="0"/>
+          </a:p>
+        </p:txBody>
+      </p:sp>
+      <p:sp>
+        <p:nvSpPr>
+          <p:cNvPr id="19" name="Text 17"/>
+          <p:cNvSpPr/>
+          <p:nvPr/>
+        </p:nvSpPr>
+        <p:spPr>
+          <a:xfrm>
+            <a:off x="8292389" y="2450592"/>
+            <a:ext cx="3012338" cy="1335024"/>
+          </a:xfrm>
+          <a:prstGeom prst="rect">
+            <a:avLst/>
+          </a:prstGeom>
+          <a:noFill/>
+          <a:ln/>
+        </p:spPr>
+        <p:txBody>
+          <a:bodyPr wrap="square" lIns="0" tIns="0" rIns="0" bIns="0" rtlCol="0" anchor="t"/>
+          <a:lstStyle/>
+          <a:p>
+            <a:pPr algn="l" indent="0" marL="0">
+              <a:lnSpc>
+                <a:spcPct val="106000"/>
+              </a:lnSpc>
+              <a:spcAft>
+                <a:spcPts val="300"/>
+              </a:spcAft>
+              <a:buNone/>
+            </a:pPr>
+            <a:r>
+              <a:rPr lang="en-US" sz="1250" dirty="0">
+                <a:solidFill>
+                  <a:srgbClr val="536177"/>
+                </a:solidFill>
+                <a:latin typeface="Calibri" pitchFamily="34" charset="0"/>
+                <a:ea typeface="Calibri" pitchFamily="34" charset="-122"/>
+                <a:cs typeface="Calibri" pitchFamily="34" charset="-120"/>
+              </a:rPr>
+              <a:t>Every fact grounded to a section + excerpt a reviewer can locate.</a:t>
+            </a:r>
+            <a:endParaRPr lang="en-US" sz="1250" dirty="0"/>
+          </a:p>
+        </p:txBody>
+      </p:sp>
+      <p:sp>
+        <p:nvSpPr>
+          <p:cNvPr id="20" name="Shape 18"/>
+          <p:cNvSpPr/>
+          <p:nvPr/>
+        </p:nvSpPr>
+        <p:spPr>
+          <a:xfrm>
+            <a:off x="640080" y="4059936"/>
+            <a:ext cx="3515258" cy="2066544"/>
+          </a:xfrm>
+          <a:prstGeom prst="roundRect">
+            <a:avLst>
+              <a:gd name="adj" fmla="val 2212"/>
+            </a:avLst>
+          </a:prstGeom>
+          <a:solidFill>
+            <a:srgbClr val="F4F7FB"/>
+          </a:solidFill>
+          <a:ln w="12700">
+            <a:solidFill>
+              <a:srgbClr val="DDE4EE"/>
+            </a:solidFill>
+            <a:prstDash val="solid"/>
+          </a:ln>
+          <a:effectLst>
+            <a:outerShdw sx="100000" sy="100000" kx="0" ky="0" algn="bl" rotWithShape="0" blurRad="88900" dist="38100" dir="5400000">
+              <a:srgbClr val="1B2A4A">
+                <a:alpha val="12000"/>
+              </a:srgbClr>
+            </a:outerShdw>
+          </a:effectLst>
+        </p:spPr>
+      </p:sp>
+      <p:sp>
+        <p:nvSpPr>
+          <p:cNvPr id="21" name="Shape 19"/>
+          <p:cNvSpPr/>
+          <p:nvPr/>
+        </p:nvSpPr>
+        <p:spPr>
+          <a:xfrm>
+            <a:off x="640080" y="4059936"/>
+            <a:ext cx="82296" cy="2066544"/>
+          </a:xfrm>
+          <a:prstGeom prst="rect">
+            <a:avLst/>
+          </a:prstGeom>
+          <a:solidFill>
+            <a:srgbClr val="2B59D6"/>
+          </a:solidFill>
+          <a:ln/>
+        </p:spPr>
+      </p:sp>
+      <p:sp>
+        <p:nvSpPr>
+          <p:cNvPr id="22" name="Text 20"/>
+          <p:cNvSpPr/>
+          <p:nvPr/>
+        </p:nvSpPr>
+        <p:spPr>
+          <a:xfrm>
+            <a:off x="896112" y="4261104"/>
+            <a:ext cx="3058058" cy="365760"/>
+          </a:xfrm>
+          <a:prstGeom prst="rect">
+            <a:avLst/>
+          </a:prstGeom>
+          <a:noFill/>
+          <a:ln/>
+        </p:spPr>
+        <p:txBody>
+          <a:bodyPr wrap="square" lIns="0" tIns="0" rIns="0" bIns="0" rtlCol="0" anchor="t"/>
+          <a:lstStyle/>
+          <a:p>
+            <a:pPr algn="l" indent="0" marL="0">
+              <a:lnSpc>
+                <a:spcPct val="100000"/>
+              </a:lnSpc>
+              <a:buNone/>
+            </a:pPr>
+            <a:r>
+              <a:rPr lang="en-US" sz="1500" b="1" dirty="0">
+                <a:solidFill>
+                  <a:srgbClr val="1B2A4A"/>
+                </a:solidFill>
+                <a:latin typeface="Calibri" pitchFamily="34" charset="0"/>
+                <a:ea typeface="Calibri" pitchFamily="34" charset="-122"/>
+                <a:cs typeface="Calibri" pitchFamily="34" charset="-120"/>
+              </a:rPr>
+              <a:t>Data provenance</a:t>
+            </a:r>
+            <a:endParaRPr lang="en-US" sz="1500" dirty="0"/>
+          </a:p>
+        </p:txBody>
+      </p:sp>
+      <p:sp>
+        <p:nvSpPr>
+          <p:cNvPr id="23" name="Text 21"/>
+          <p:cNvSpPr/>
+          <p:nvPr/>
+        </p:nvSpPr>
+        <p:spPr>
+          <a:xfrm>
+            <a:off x="896112" y="4681728"/>
+            <a:ext cx="3012338" cy="1335024"/>
+          </a:xfrm>
+          <a:prstGeom prst="rect">
+            <a:avLst/>
+          </a:prstGeom>
+          <a:noFill/>
+          <a:ln/>
+        </p:spPr>
+        <p:txBody>
+          <a:bodyPr wrap="square" lIns="0" tIns="0" rIns="0" bIns="0" rtlCol="0" anchor="t"/>
+          <a:lstStyle/>
+          <a:p>
+            <a:pPr algn="l" indent="0" marL="0">
+              <a:lnSpc>
+                <a:spcPct val="106000"/>
+              </a:lnSpc>
+              <a:spcAft>
+                <a:spcPts val="300"/>
+              </a:spcAft>
+              <a:buNone/>
+            </a:pPr>
+            <a:r>
+              <a:rPr lang="en-US" sz="1250" dirty="0">
+                <a:solidFill>
+                  <a:srgbClr val="536177"/>
+                </a:solidFill>
+                <a:latin typeface="Calibri" pitchFamily="34" charset="0"/>
+                <a:ea typeface="Calibri" pitchFamily="34" charset="-122"/>
+                <a:cs typeface="Calibri" pitchFamily="34" charset="-120"/>
+              </a:rPr>
+              <a:t>Every tape is tagged with its source — deeploans (the organiser's own ESMA ETL) or a direct read — and the tag travels into the evidence pack. This demo runs direct for infra reasons; the deeploans path is wired and selectable.</a:t>
+            </a:r>
+            <a:endParaRPr lang="en-US" sz="1250" dirty="0"/>
+          </a:p>
+        </p:txBody>
+      </p:sp>
+      <p:sp>
+        <p:nvSpPr>
+          <p:cNvPr id="24" name="Shape 22"/>
+          <p:cNvSpPr/>
+          <p:nvPr/>
+        </p:nvSpPr>
+        <p:spPr>
+          <a:xfrm>
+            <a:off x="4338218" y="4059936"/>
+            <a:ext cx="3515258" cy="2066544"/>
+          </a:xfrm>
+          <a:prstGeom prst="roundRect">
+            <a:avLst>
+              <a:gd name="adj" fmla="val 2212"/>
+            </a:avLst>
+          </a:prstGeom>
+          <a:solidFill>
+            <a:srgbClr val="F4F7FB"/>
+          </a:solidFill>
+          <a:ln w="12700">
+            <a:solidFill>
+              <a:srgbClr val="DDE4EE"/>
+            </a:solidFill>
+            <a:prstDash val="solid"/>
+          </a:ln>
+          <a:effectLst>
+            <a:outerShdw sx="100000" sy="100000" kx="0" ky="0" algn="bl" rotWithShape="0" blurRad="88900" dist="38100" dir="5400000">
+              <a:srgbClr val="1B2A4A">
+                <a:alpha val="12000"/>
+              </a:srgbClr>
+            </a:outerShdw>
+          </a:effectLst>
+        </p:spPr>
+      </p:sp>
+      <p:sp>
+        <p:nvSpPr>
+          <p:cNvPr id="25" name="Shape 23"/>
+          <p:cNvSpPr/>
+          <p:nvPr/>
+        </p:nvSpPr>
+        <p:spPr>
+          <a:xfrm>
+            <a:off x="4338218" y="4059936"/>
+            <a:ext cx="82296" cy="2066544"/>
+          </a:xfrm>
+          <a:prstGeom prst="rect">
+            <a:avLst/>
+          </a:prstGeom>
+          <a:solidFill>
+            <a:srgbClr val="2B59D6"/>
+          </a:solidFill>
+          <a:ln/>
+        </p:spPr>
+      </p:sp>
+      <p:sp>
+        <p:nvSpPr>
+          <p:cNvPr id="26" name="Text 24"/>
+          <p:cNvSpPr/>
+          <p:nvPr/>
+        </p:nvSpPr>
+        <p:spPr>
+          <a:xfrm>
+            <a:off x="4594250" y="4261104"/>
+            <a:ext cx="3058058" cy="365760"/>
+          </a:xfrm>
+          <a:prstGeom prst="rect">
+            <a:avLst/>
+          </a:prstGeom>
+          <a:noFill/>
+          <a:ln/>
+        </p:spPr>
+        <p:txBody>
+          <a:bodyPr wrap="square" lIns="0" tIns="0" rIns="0" bIns="0" rtlCol="0" anchor="t"/>
+          <a:lstStyle/>
+          <a:p>
+            <a:pPr algn="l" indent="0" marL="0">
+              <a:lnSpc>
+                <a:spcPct val="100000"/>
+              </a:lnSpc>
+              <a:buNone/>
+            </a:pPr>
+            <a:r>
+              <a:rPr lang="en-US" sz="1500" b="1" dirty="0">
+                <a:solidFill>
+                  <a:srgbClr val="1B2A4A"/>
+                </a:solidFill>
+                <a:latin typeface="Calibri" pitchFamily="34" charset="0"/>
+                <a:ea typeface="Calibri" pitchFamily="34" charset="-122"/>
+                <a:cs typeface="Calibri" pitchFamily="34" charset="-120"/>
+              </a:rPr>
+              <a:t>Human-review routing</a:t>
+            </a:r>
+            <a:endParaRPr lang="en-US" sz="1500" dirty="0"/>
+          </a:p>
+        </p:txBody>
+      </p:sp>
+      <p:sp>
+        <p:nvSpPr>
+          <p:cNvPr id="27" name="Text 25"/>
+          <p:cNvSpPr/>
+          <p:nvPr/>
+        </p:nvSpPr>
+        <p:spPr>
+          <a:xfrm>
+            <a:off x="4594250" y="4681728"/>
+            <a:ext cx="3012338" cy="1335024"/>
+          </a:xfrm>
+          <a:prstGeom prst="rect">
+            <a:avLst/>
+          </a:prstGeom>
+          <a:noFill/>
+          <a:ln/>
+        </p:spPr>
+        <p:txBody>
+          <a:bodyPr wrap="square" lIns="0" tIns="0" rIns="0" bIns="0" rtlCol="0" anchor="t"/>
+          <a:lstStyle/>
+          <a:p>
+            <a:pPr algn="l" indent="0" marL="0">
+              <a:lnSpc>
+                <a:spcPct val="106000"/>
+              </a:lnSpc>
+              <a:spcAft>
+                <a:spcPts val="300"/>
+              </a:spcAft>
+              <a:buNone/>
+            </a:pPr>
+            <a:r>
+              <a:rPr lang="en-US" sz="1250" dirty="0">
+                <a:solidFill>
+                  <a:srgbClr val="536177"/>
+                </a:solidFill>
+                <a:latin typeface="Calibri" pitchFamily="34" charset="0"/>
+                <a:ea typeface="Calibri" pitchFamily="34" charset="-122"/>
+                <a:cs typeface="Calibri" pitchFamily="34" charset="-120"/>
+              </a:rPr>
+              <a:t>Below the confidence threshold → human_review_required; output can't be used until a reviewer signs off.</a:t>
+            </a:r>
+            <a:endParaRPr lang="en-US" sz="1250" dirty="0"/>
+          </a:p>
+        </p:txBody>
+      </p:sp>
+      <p:sp>
+        <p:nvSpPr>
+          <p:cNvPr id="28" name="Shape 26"/>
+          <p:cNvSpPr/>
+          <p:nvPr/>
+        </p:nvSpPr>
+        <p:spPr>
+          <a:xfrm>
+            <a:off x="8036357" y="4059936"/>
+            <a:ext cx="3515258" cy="2066544"/>
+          </a:xfrm>
+          <a:prstGeom prst="roundRect">
+            <a:avLst>
+              <a:gd name="adj" fmla="val 2212"/>
+            </a:avLst>
+          </a:prstGeom>
+          <a:solidFill>
+            <a:srgbClr val="F4F7FB"/>
+          </a:solidFill>
+          <a:ln w="12700">
+            <a:solidFill>
+              <a:srgbClr val="DDE4EE"/>
+            </a:solidFill>
+            <a:prstDash val="solid"/>
+          </a:ln>
+          <a:effectLst>
+            <a:outerShdw sx="100000" sy="100000" kx="0" ky="0" algn="bl" rotWithShape="0" blurRad="88900" dist="38100" dir="5400000">
+              <a:srgbClr val="1B2A4A">
+                <a:alpha val="12000"/>
+              </a:srgbClr>
+            </a:outerShdw>
+          </a:effectLst>
+        </p:spPr>
+      </p:sp>
+      <p:sp>
+        <p:nvSpPr>
+          <p:cNvPr id="29" name="Shape 27"/>
+          <p:cNvSpPr/>
+          <p:nvPr/>
+        </p:nvSpPr>
+        <p:spPr>
+          <a:xfrm>
+            <a:off x="8036357" y="4059936"/>
+            <a:ext cx="82296" cy="2066544"/>
+          </a:xfrm>
+          <a:prstGeom prst="rect">
+            <a:avLst/>
+          </a:prstGeom>
+          <a:solidFill>
+            <a:srgbClr val="2B59D6"/>
+          </a:solidFill>
+          <a:ln/>
+        </p:spPr>
+      </p:sp>
+      <p:sp>
+        <p:nvSpPr>
+          <p:cNvPr id="30" name="Text 28"/>
+          <p:cNvSpPr/>
+          <p:nvPr/>
+        </p:nvSpPr>
+        <p:spPr>
+          <a:xfrm>
+            <a:off x="8292389" y="4261104"/>
+            <a:ext cx="3058058" cy="365760"/>
+          </a:xfrm>
+          <a:prstGeom prst="rect">
+            <a:avLst/>
+          </a:prstGeom>
+          <a:noFill/>
+          <a:ln/>
+        </p:spPr>
+        <p:txBody>
+          <a:bodyPr wrap="square" lIns="0" tIns="0" rIns="0" bIns="0" rtlCol="0" anchor="t"/>
+          <a:lstStyle/>
+          <a:p>
+            <a:pPr algn="l" indent="0" marL="0">
+              <a:lnSpc>
+                <a:spcPct val="100000"/>
+              </a:lnSpc>
+              <a:buNone/>
+            </a:pPr>
+            <a:r>
+              <a:rPr lang="en-US" sz="1500" b="1" dirty="0">
+                <a:solidFill>
+                  <a:srgbClr val="1B2A4A"/>
+                </a:solidFill>
+                <a:latin typeface="Calibri" pitchFamily="34" charset="0"/>
+                <a:ea typeface="Calibri" pitchFamily="34" charset="-122"/>
+                <a:cs typeface="Calibri" pitchFamily="34" charset="-120"/>
+              </a:rPr>
+              <a:t>Model-risk class</a:t>
+            </a:r>
+            <a:endParaRPr lang="en-US" sz="1500" dirty="0"/>
+          </a:p>
+        </p:txBody>
+      </p:sp>
+      <p:sp>
+        <p:nvSpPr>
+          <p:cNvPr id="31" name="Text 29"/>
+          <p:cNvSpPr/>
+          <p:nvPr/>
+        </p:nvSpPr>
+        <p:spPr>
+          <a:xfrm>
+            <a:off x="8292389" y="4681728"/>
+            <a:ext cx="3012338" cy="1335024"/>
+          </a:xfrm>
+          <a:prstGeom prst="rect">
+            <a:avLst/>
+          </a:prstGeom>
+          <a:noFill/>
+          <a:ln/>
+        </p:spPr>
+        <p:txBody>
+          <a:bodyPr wrap="square" lIns="0" tIns="0" rIns="0" bIns="0" rtlCol="0" anchor="t"/>
+          <a:lstStyle/>
+          <a:p>
+            <a:pPr algn="l" indent="0" marL="0">
+              <a:lnSpc>
+                <a:spcPct val="106000"/>
+              </a:lnSpc>
+              <a:spcAft>
+                <a:spcPts val="300"/>
+              </a:spcAft>
+              <a:buNone/>
+            </a:pPr>
+            <a:r>
+              <a:rPr lang="en-US" sz="1250" dirty="0">
+                <a:solidFill>
+                  <a:srgbClr val="536177"/>
+                </a:solidFill>
+                <a:latin typeface="Calibri" pitchFamily="34" charset="0"/>
+                <a:ea typeface="Calibri" pitchFamily="34" charset="-122"/>
+                <a:cs typeface="Calibri" pitchFamily="34" charset="-120"/>
+              </a:rPr>
+              <a:t>Decision-support tier, zero autonomy — outputs are inputs, never actions.</a:t>
             </a:r>
             <a:endParaRPr lang="en-US" sz="1250" dirty="0"/>
           </a:p>
@@ -8462,7 +9095,7 @@
     <p:bg>
       <p:bgPr>
         <a:solidFill>
-          <a:srgbClr val="1B2A4A"/>
+          <a:srgbClr val="FFFFFF"/>
         </a:solidFill>
       </p:bgPr>
     </p:bg>
@@ -8495,6 +9128,110 @@
             <a:avLst/>
           </a:prstGeom>
           <a:solidFill>
+            <a:srgbClr val="2B59D6"/>
+          </a:solidFill>
+          <a:ln/>
+        </p:spPr>
+      </p:sp>
+      <p:sp>
+        <p:nvSpPr>
+          <p:cNvPr id="3" name="Text 1"/>
+          <p:cNvSpPr/>
+          <p:nvPr/>
+        </p:nvSpPr>
+        <p:spPr>
+          <a:xfrm>
+            <a:off x="640080" y="384048"/>
+            <a:ext cx="10789920" cy="274320"/>
+          </a:xfrm>
+          <a:prstGeom prst="rect">
+            <a:avLst/>
+          </a:prstGeom>
+          <a:noFill/>
+          <a:ln/>
+        </p:spPr>
+        <p:txBody>
+          <a:bodyPr wrap="square" lIns="0" tIns="0" rIns="0" bIns="0" rtlCol="0" anchor="t"/>
+          <a:lstStyle/>
+          <a:p>
+            <a:pPr algn="l" indent="0" marL="0">
+              <a:lnSpc>
+                <a:spcPct val="100000"/>
+              </a:lnSpc>
+              <a:buNone/>
+            </a:pPr>
+            <a:r>
+              <a:rPr lang="en-US" sz="1200" b="1" dirty="0">
+                <a:solidFill>
+                  <a:srgbClr val="129E8F"/>
+                </a:solidFill>
+                <a:latin typeface="Calibri" pitchFamily="34" charset="0"/>
+                <a:ea typeface="Calibri" pitchFamily="34" charset="-122"/>
+                <a:cs typeface="Calibri" pitchFamily="34" charset="-120"/>
+              </a:rPr>
+              <a:t>WHAT WE BUILT — THE DASHBOARD</a:t>
+            </a:r>
+            <a:endParaRPr lang="en-US" sz="1200" dirty="0"/>
+          </a:p>
+        </p:txBody>
+      </p:sp>
+      <p:sp>
+        <p:nvSpPr>
+          <p:cNvPr id="4" name="Text 2"/>
+          <p:cNvSpPr/>
+          <p:nvPr/>
+        </p:nvSpPr>
+        <p:spPr>
+          <a:xfrm>
+            <a:off x="640080" y="658368"/>
+            <a:ext cx="10881360" cy="822960"/>
+          </a:xfrm>
+          <a:prstGeom prst="rect">
+            <a:avLst/>
+          </a:prstGeom>
+          <a:noFill/>
+          <a:ln/>
+        </p:spPr>
+        <p:txBody>
+          <a:bodyPr wrap="square" lIns="0" tIns="0" rIns="0" bIns="0" rtlCol="0" anchor="t"/>
+          <a:lstStyle/>
+          <a:p>
+            <a:pPr algn="l" indent="0" marL="0">
+              <a:lnSpc>
+                <a:spcPct val="100000"/>
+              </a:lnSpc>
+              <a:buNone/>
+            </a:pPr>
+            <a:r>
+              <a:rPr lang="en-US" sz="2800" b="1" dirty="0">
+                <a:solidFill>
+                  <a:srgbClr val="1B2A4A"/>
+                </a:solidFill>
+                <a:latin typeface="Calibri" pitchFamily="34" charset="0"/>
+                <a:ea typeface="Calibri" pitchFamily="34" charset="-122"/>
+                <a:cs typeface="Calibri" pitchFamily="34" charset="-120"/>
+              </a:rPr>
+              <a:t>Two layers, one product</a:t>
+            </a:r>
+            <a:endParaRPr lang="en-US" sz="2800" dirty="0"/>
+          </a:p>
+        </p:txBody>
+      </p:sp>
+      <p:sp>
+        <p:nvSpPr>
+          <p:cNvPr id="5" name="Shape 3"/>
+          <p:cNvSpPr/>
+          <p:nvPr/>
+        </p:nvSpPr>
+        <p:spPr>
+          <a:xfrm>
+            <a:off x="658368" y="1335024"/>
+            <a:ext cx="548640" cy="36576"/>
+          </a:xfrm>
+          <a:prstGeom prst="rect">
+            <a:avLst/>
+          </a:prstGeom>
+          <a:solidFill>
             <a:srgbClr val="129E8F"/>
           </a:solidFill>
           <a:ln/>
@@ -8502,14 +9239,14 @@
       </p:sp>
       <p:sp>
         <p:nvSpPr>
-          <p:cNvPr id="3" name="Text 1"/>
-          <p:cNvSpPr/>
-          <p:nvPr/>
-        </p:nvSpPr>
-        <p:spPr>
-          <a:xfrm>
-            <a:off x="868680" y="2468880"/>
-            <a:ext cx="10058400" cy="365760"/>
+          <p:cNvPr id="6" name="Text 4"/>
+          <p:cNvSpPr/>
+          <p:nvPr/>
+        </p:nvSpPr>
+        <p:spPr>
+          <a:xfrm>
+            <a:off x="640080" y="6437376"/>
+            <a:ext cx="7315200" cy="274320"/>
           </a:xfrm>
           <a:prstGeom prst="rect">
             <a:avLst/>
@@ -8528,30 +9265,47 @@
               <a:buNone/>
             </a:pPr>
             <a:r>
-              <a:rPr lang="en-US" sz="1300" b="1" dirty="0">
-                <a:solidFill>
-                  <a:srgbClr val="129E8F"/>
-                </a:solidFill>
-                <a:latin typeface="Calibri" pitchFamily="34" charset="0"/>
-                <a:ea typeface="Calibri" pitchFamily="34" charset="-122"/>
-                <a:cs typeface="Calibri" pitchFamily="34" charset="-120"/>
-              </a:rPr>
-              <a:t>WHY IT ANSWERS THE CHALLENGE</a:t>
-            </a:r>
-            <a:endParaRPr lang="en-US" sz="1300" dirty="0"/>
-          </a:p>
-        </p:txBody>
-      </p:sp>
-      <p:sp>
-        <p:nvSpPr>
-          <p:cNvPr id="4" name="Text 2"/>
-          <p:cNvSpPr/>
-          <p:nvPr/>
-        </p:nvSpPr>
-        <p:spPr>
-          <a:xfrm>
-            <a:off x="841248" y="2880360"/>
-            <a:ext cx="10424160" cy="1097280"/>
+              <a:rPr lang="en-US" sz="900" b="1" dirty="0">
+                <a:solidFill>
+                  <a:srgbClr val="536177"/>
+                </a:solidFill>
+                <a:latin typeface="Calibri" pitchFamily="34" charset="0"/>
+                <a:ea typeface="Calibri" pitchFamily="34" charset="-122"/>
+                <a:cs typeface="Calibri" pitchFamily="34" charset="-120"/>
+              </a:rPr>
+              <a:t>LoanWhiz</a:t>
+            </a:r>
+            <a:pPr algn="l" indent="0" marL="0">
+              <a:lnSpc>
+                <a:spcPct val="100000"/>
+              </a:lnSpc>
+              <a:buNone/>
+            </a:pPr>
+            <a:r>
+              <a:rPr lang="en-US" sz="900" dirty="0">
+                <a:solidFill>
+                  <a:srgbClr val="6B7A90"/>
+                </a:solidFill>
+                <a:latin typeface="Calibri" pitchFamily="34" charset="0"/>
+                <a:ea typeface="Calibri" pitchFamily="34" charset="-122"/>
+                <a:cs typeface="Calibri" pitchFamily="34" charset="-120"/>
+              </a:rPr>
+              <a:t>  ·  Structured Finance Agent Framework</a:t>
+            </a:r>
+            <a:endParaRPr lang="en-US" sz="900" dirty="0"/>
+          </a:p>
+        </p:txBody>
+      </p:sp>
+      <p:sp>
+        <p:nvSpPr>
+          <p:cNvPr id="7" name="Text 5"/>
+          <p:cNvSpPr/>
+          <p:nvPr/>
+        </p:nvSpPr>
+        <p:spPr>
+          <a:xfrm>
+            <a:off x="10058400" y="6437376"/>
+            <a:ext cx="502920" cy="274320"/>
           </a:xfrm>
           <a:prstGeom prst="rect">
             <a:avLst/>
@@ -8563,6 +9317,102 @@
           <a:bodyPr wrap="square" lIns="0" tIns="0" rIns="0" bIns="0" rtlCol="0" anchor="t"/>
           <a:lstStyle/>
           <a:p>
+            <a:pPr algn="r" indent="0" marL="0">
+              <a:lnSpc>
+                <a:spcPct val="100000"/>
+              </a:lnSpc>
+              <a:buNone/>
+            </a:pPr>
+            <a:r>
+              <a:rPr lang="en-US" sz="900" dirty="0">
+                <a:solidFill>
+                  <a:srgbClr val="6B7A90"/>
+                </a:solidFill>
+                <a:latin typeface="Calibri" pitchFamily="34" charset="0"/>
+                <a:ea typeface="Calibri" pitchFamily="34" charset="-122"/>
+                <a:cs typeface="Calibri" pitchFamily="34" charset="-120"/>
+              </a:rPr>
+              <a:t>09</a:t>
+            </a:r>
+            <a:endParaRPr lang="en-US" sz="900" dirty="0"/>
+          </a:p>
+        </p:txBody>
+      </p:sp>
+      <p:sp>
+        <p:nvSpPr>
+          <p:cNvPr id="8" name="Shape 6"/>
+          <p:cNvSpPr/>
+          <p:nvPr/>
+        </p:nvSpPr>
+        <p:spPr>
+          <a:xfrm>
+            <a:off x="640080" y="1828800"/>
+            <a:ext cx="5364328" cy="4297680"/>
+          </a:xfrm>
+          <a:prstGeom prst="roundRect">
+            <a:avLst>
+              <a:gd name="adj" fmla="val 1064"/>
+            </a:avLst>
+          </a:prstGeom>
+          <a:solidFill>
+            <a:srgbClr val="F4F7FB"/>
+          </a:solidFill>
+          <a:ln w="12700">
+            <a:solidFill>
+              <a:srgbClr val="DDE4EE"/>
+            </a:solidFill>
+            <a:prstDash val="solid"/>
+          </a:ln>
+          <a:effectLst>
+            <a:outerShdw sx="100000" sy="100000" kx="0" ky="0" algn="bl" rotWithShape="0" blurRad="88900" dist="38100" dir="5400000">
+              <a:srgbClr val="1B2A4A">
+                <a:alpha val="12000"/>
+              </a:srgbClr>
+            </a:outerShdw>
+          </a:effectLst>
+        </p:spPr>
+      </p:sp>
+      <p:sp>
+        <p:nvSpPr>
+          <p:cNvPr id="9" name="Shape 7"/>
+          <p:cNvSpPr/>
+          <p:nvPr/>
+        </p:nvSpPr>
+        <p:spPr>
+          <a:xfrm>
+            <a:off x="640080" y="1828800"/>
+            <a:ext cx="82296" cy="4297680"/>
+          </a:xfrm>
+          <a:prstGeom prst="rect">
+            <a:avLst/>
+          </a:prstGeom>
+          <a:solidFill>
+            <a:srgbClr val="1B2A4A"/>
+          </a:solidFill>
+          <a:ln/>
+        </p:spPr>
+      </p:sp>
+      <p:sp>
+        <p:nvSpPr>
+          <p:cNvPr id="10" name="Text 8"/>
+          <p:cNvSpPr/>
+          <p:nvPr/>
+        </p:nvSpPr>
+        <p:spPr>
+          <a:xfrm>
+            <a:off x="896112" y="2029968"/>
+            <a:ext cx="4907128" cy="365760"/>
+          </a:xfrm>
+          <a:prstGeom prst="rect">
+            <a:avLst/>
+          </a:prstGeom>
+          <a:noFill/>
+          <a:ln/>
+        </p:spPr>
+        <p:txBody>
+          <a:bodyPr wrap="square" lIns="0" tIns="0" rIns="0" bIns="0" rtlCol="0" anchor="t"/>
+          <a:lstStyle/>
+          <a:p>
             <a:pPr algn="l" indent="0" marL="0">
               <a:lnSpc>
                 <a:spcPct val="100000"/>
@@ -8570,30 +9420,30 @@
               <a:buNone/>
             </a:pPr>
             <a:r>
-              <a:rPr lang="en-US" sz="4000" b="1" dirty="0">
-                <a:solidFill>
-                  <a:srgbClr val="FFFFFF"/>
-                </a:solidFill>
-                <a:latin typeface="Calibri" pitchFamily="34" charset="0"/>
-                <a:ea typeface="Calibri" pitchFamily="34" charset="-122"/>
-                <a:cs typeface="Calibri" pitchFamily="34" charset="-120"/>
-              </a:rPr>
-              <a:t>Reusable, trustworthy, broadly applicable</a:t>
-            </a:r>
-            <a:endParaRPr lang="en-US" sz="4000" dirty="0"/>
-          </a:p>
-        </p:txBody>
-      </p:sp>
-      <p:sp>
-        <p:nvSpPr>
-          <p:cNvPr id="5" name="Text 3"/>
-          <p:cNvSpPr/>
-          <p:nvPr/>
-        </p:nvSpPr>
-        <p:spPr>
-          <a:xfrm>
-            <a:off x="868680" y="3977640"/>
-            <a:ext cx="9875520" cy="1097280"/>
+              <a:rPr lang="en-US" sz="1500" b="1" dirty="0">
+                <a:solidFill>
+                  <a:srgbClr val="1B2A4A"/>
+                </a:solidFill>
+                <a:latin typeface="Calibri" pitchFamily="34" charset="0"/>
+                <a:ea typeface="Calibri" pitchFamily="34" charset="-122"/>
+                <a:cs typeface="Calibri" pitchFamily="34" charset="-120"/>
+              </a:rPr>
+              <a:t>Deal Analytics</a:t>
+            </a:r>
+            <a:endParaRPr lang="en-US" sz="1500" dirty="0"/>
+          </a:p>
+        </p:txBody>
+      </p:sp>
+      <p:sp>
+        <p:nvSpPr>
+          <p:cNvPr id="11" name="Text 9"/>
+          <p:cNvSpPr/>
+          <p:nvPr/>
+        </p:nvSpPr>
+        <p:spPr>
+          <a:xfrm>
+            <a:off x="896112" y="2450592"/>
+            <a:ext cx="4861408" cy="3566160"/>
           </a:xfrm>
           <a:prstGeom prst="rect">
             <a:avLst/>
@@ -8607,22 +9457,166 @@
           <a:p>
             <a:pPr algn="l" indent="0" marL="0">
               <a:lnSpc>
-                <a:spcPct val="120000"/>
-              </a:lnSpc>
-              <a:buNone/>
-            </a:pPr>
-            <a:r>
-              <a:rPr lang="en-US" sz="1600" dirty="0">
-                <a:solidFill>
-                  <a:srgbClr val="C7D3E8"/>
-                </a:solidFill>
-                <a:latin typeface="Calibri" pitchFamily="34" charset="0"/>
-                <a:ea typeface="Calibri" pitchFamily="34" charset="-122"/>
-                <a:cs typeface="Calibri" pitchFamily="34" charset="-120"/>
-              </a:rPr>
-              <a:t>SF-native primitives + a registry, packaged as an MCP — not a one-off script. Validated to the cent against a real ING deal, demonstrated across Dutch, Italian and Spanish RMBS, with citations, governance and data-provenance on every output. And honest about its limits — the capability matrix shows exactly what's proven.</a:t>
-            </a:r>
-            <a:endParaRPr lang="en-US" sz="1600" dirty="0"/>
+                <a:spcPct val="106000"/>
+              </a:lnSpc>
+              <a:spcAft>
+                <a:spcPts val="300"/>
+              </a:spcAft>
+              <a:buNone/>
+            </a:pPr>
+            <a:r>
+              <a:rPr lang="en-US" sz="1250" dirty="0">
+                <a:solidFill>
+                  <a:srgbClr val="536177"/>
+                </a:solidFill>
+                <a:latin typeface="Calibri" pitchFamily="34" charset="0"/>
+                <a:ea typeface="Calibri" pitchFamily="34" charset="-122"/>
+                <a:cs typeface="Calibri" pitchFamily="34" charset="-120"/>
+              </a:rPr>
+              <a:t>Overview · Pool &amp; Performance · Waterfall · Compliance · Projection — the per-deal analyst workflow over the extracted model.</a:t>
+            </a:r>
+            <a:endParaRPr lang="en-US" sz="1250" dirty="0"/>
+          </a:p>
+        </p:txBody>
+      </p:sp>
+      <p:sp>
+        <p:nvSpPr>
+          <p:cNvPr id="12" name="Shape 10"/>
+          <p:cNvSpPr/>
+          <p:nvPr/>
+        </p:nvSpPr>
+        <p:spPr>
+          <a:xfrm>
+            <a:off x="6187288" y="1828800"/>
+            <a:ext cx="5364328" cy="4297680"/>
+          </a:xfrm>
+          <a:prstGeom prst="roundRect">
+            <a:avLst>
+              <a:gd name="adj" fmla="val 1064"/>
+            </a:avLst>
+          </a:prstGeom>
+          <a:solidFill>
+            <a:srgbClr val="F4F7FB"/>
+          </a:solidFill>
+          <a:ln w="12700">
+            <a:solidFill>
+              <a:srgbClr val="DDE4EE"/>
+            </a:solidFill>
+            <a:prstDash val="solid"/>
+          </a:ln>
+          <a:effectLst>
+            <a:outerShdw sx="100000" sy="100000" kx="0" ky="0" algn="bl" rotWithShape="0" blurRad="88900" dist="38100" dir="5400000">
+              <a:srgbClr val="1B2A4A">
+                <a:alpha val="12000"/>
+              </a:srgbClr>
+            </a:outerShdw>
+          </a:effectLst>
+        </p:spPr>
+      </p:sp>
+      <p:sp>
+        <p:nvSpPr>
+          <p:cNvPr id="13" name="Shape 11"/>
+          <p:cNvSpPr/>
+          <p:nvPr/>
+        </p:nvSpPr>
+        <p:spPr>
+          <a:xfrm>
+            <a:off x="6187288" y="1828800"/>
+            <a:ext cx="82296" cy="4297680"/>
+          </a:xfrm>
+          <a:prstGeom prst="rect">
+            <a:avLst/>
+          </a:prstGeom>
+          <a:solidFill>
+            <a:srgbClr val="2B59D6"/>
+          </a:solidFill>
+          <a:ln/>
+        </p:spPr>
+      </p:sp>
+      <p:sp>
+        <p:nvSpPr>
+          <p:cNvPr id="14" name="Text 12"/>
+          <p:cNvSpPr/>
+          <p:nvPr/>
+        </p:nvSpPr>
+        <p:spPr>
+          <a:xfrm>
+            <a:off x="6443320" y="2029968"/>
+            <a:ext cx="4907128" cy="365760"/>
+          </a:xfrm>
+          <a:prstGeom prst="rect">
+            <a:avLst/>
+          </a:prstGeom>
+          <a:noFill/>
+          <a:ln/>
+        </p:spPr>
+        <p:txBody>
+          <a:bodyPr wrap="square" lIns="0" tIns="0" rIns="0" bIns="0" rtlCol="0" anchor="t"/>
+          <a:lstStyle/>
+          <a:p>
+            <a:pPr algn="l" indent="0" marL="0">
+              <a:lnSpc>
+                <a:spcPct val="100000"/>
+              </a:lnSpc>
+              <a:buNone/>
+            </a:pPr>
+            <a:r>
+              <a:rPr lang="en-US" sz="1500" b="1" dirty="0">
+                <a:solidFill>
+                  <a:srgbClr val="1B2A4A"/>
+                </a:solidFill>
+                <a:latin typeface="Calibri" pitchFamily="34" charset="0"/>
+                <a:ea typeface="Calibri" pitchFamily="34" charset="-122"/>
+                <a:cs typeface="Calibri" pitchFamily="34" charset="-120"/>
+              </a:rPr>
+              <a:t>Platform &amp; Governance</a:t>
+            </a:r>
+            <a:endParaRPr lang="en-US" sz="1500" dirty="0"/>
+          </a:p>
+        </p:txBody>
+      </p:sp>
+      <p:sp>
+        <p:nvSpPr>
+          <p:cNvPr id="15" name="Text 13"/>
+          <p:cNvSpPr/>
+          <p:nvPr/>
+        </p:nvSpPr>
+        <p:spPr>
+          <a:xfrm>
+            <a:off x="6443320" y="2450592"/>
+            <a:ext cx="4861408" cy="3566160"/>
+          </a:xfrm>
+          <a:prstGeom prst="rect">
+            <a:avLst/>
+          </a:prstGeom>
+          <a:noFill/>
+          <a:ln/>
+        </p:spPr>
+        <p:txBody>
+          <a:bodyPr wrap="square" lIns="0" tIns="0" rIns="0" bIns="0" rtlCol="0" anchor="t"/>
+          <a:lstStyle/>
+          <a:p>
+            <a:pPr algn="l" indent="0" marL="0">
+              <a:lnSpc>
+                <a:spcPct val="106000"/>
+              </a:lnSpc>
+              <a:spcAft>
+                <a:spcPts val="300"/>
+              </a:spcAft>
+              <a:buNone/>
+            </a:pPr>
+            <a:r>
+              <a:rPr lang="en-US" sz="1250" dirty="0">
+                <a:solidFill>
+                  <a:srgbClr val="536177"/>
+                </a:solidFill>
+                <a:latin typeface="Calibri" pitchFamily="34" charset="0"/>
+                <a:ea typeface="Calibri" pitchFamily="34" charset="-122"/>
+                <a:cs typeface="Calibri" pitchFamily="34" charset="-120"/>
+              </a:rPr>
+              <a:t>Showcase · Validation · Framework · Governance — the cross-deal, trust &amp; reusability layer that headlines the work.</a:t>
+            </a:r>
+            <a:endParaRPr lang="en-US" sz="1250" dirty="0"/>
           </a:p>
         </p:txBody>
       </p:sp>

</xml_diff>